<commit_message>
Integrer la H2 validee par le prof : composition des retards
- notebook : section H2 restructuree en trois actes (test direct de
  composition, mecanisme distance, contre-analyse compagnies), verdict
  Refutee (les vols longs portent 13 % des retards), re-execution
  complete sur les donnees brutes Kaggle (data/ exclu du repo)
- dashboard v2 : nouvelle carte composition en colonnes verticales,
  nuage des compagnies elargi et retitre en question, cartes rendues
  elastiques (plus d'ecrasement aux petites resolutions), donnees
  separees dans dashboard_data_v2.js - originaux toujours intacts
- v2/ : exports regeneres par le notebook (CSV, figures, resume, donnees)
- presentation : slide hypotheses avec la formulation validee, verdict
  de conclusion mis a jour, capture du dashboard rafraichie, images
  orphelines purgees (3,7 -> 0,8 Mo)

Co-Authored-By: Claude Fable 5 <noreply@anthropic.com>
</commit_message>
<xml_diff>
--- a/rendu_presentation_v2.pptx
+++ b/rendu_presentation_v2.pptx
@@ -5680,7 +5680,7 @@
                 </a:solidFill>
                 <a:latin typeface="Calibri"/>
               </a:rPr>
-              <a:t>Plus une compagnie fait de vols longue distance, plus ses vols sont en retard.</a:t>
+              <a:t>Les longs courriers composent la plus grande majorité des retards.</a:t>
             </a:r>
           </a:p>
         </p:txBody>
@@ -6021,30 +6021,6 @@
           </a:p>
         </p:txBody>
       </p:sp>
-      <p:pic>
-        <p:nvPicPr>
-          <p:cNvPr id="5" name="Picture 4" descr="pptx_image1.png"/>
-          <p:cNvPicPr>
-            <a:picLocks noChangeAspect="1"/>
-          </p:cNvPicPr>
-          <p:nvPr/>
-        </p:nvPicPr>
-        <p:blipFill>
-          <a:blip r:embed="rId2"/>
-          <a:stretch>
-            <a:fillRect/>
-          </a:stretch>
-        </p:blipFill>
-        <p:spPr>
-          <a:xfrm>
-            <a:off x="86265" y="294184"/>
-            <a:ext cx="12019164" cy="6481520"/>
-          </a:xfrm>
-          <a:prstGeom prst="rect">
-            <a:avLst/>
-          </a:prstGeom>
-        </p:spPr>
-      </p:pic>
       <p:sp>
         <p:nvSpPr>
           <p:cNvPr id="7" name="TextBox 6"/>
@@ -6084,6 +6060,30 @@
           </a:p>
         </p:txBody>
       </p:sp>
+      <p:pic>
+        <p:nvPicPr>
+          <p:cNvPr id="8" name="Picture 7" descr="capture_dashboard_v2_commit.png"/>
+          <p:cNvPicPr>
+            <a:picLocks noChangeAspect="1"/>
+          </p:cNvPicPr>
+          <p:nvPr/>
+        </p:nvPicPr>
+        <p:blipFill>
+          <a:blip r:embed="rId6"/>
+          <a:stretch>
+            <a:fillRect/>
+          </a:stretch>
+        </p:blipFill>
+        <p:spPr>
+          <a:xfrm>
+            <a:off x="334686" y="294184"/>
+            <a:ext cx="11522628" cy="6481520"/>
+          </a:xfrm>
+          <a:prstGeom prst="rect">
+            <a:avLst/>
+          </a:prstGeom>
+        </p:spPr>
+      </p:pic>
     </p:spTree>
   </p:cSld>
   <p:clrMapOvr>
@@ -6500,7 +6500,7 @@
                 </a:solidFill>
                 <a:latin typeface="Calibri"/>
               </a:rPr>
-              <a:t>NON VALIDÉE</a:t>
+              <a:t>RÉFUTÉE</a:t>
             </a:r>
           </a:p>
         </p:txBody>
@@ -6542,7 +6542,7 @@
                 </a:solidFill>
                 <a:latin typeface="Calibri"/>
               </a:rPr>
-              <a:t>La distance ne dégrade pas la ponctualité : les vols longs rattrapent jusqu'à 9 minutes en vol. C'est le modèle d'exploitation de la compagnie qui fait la différence.</a:t>
+              <a:t>Les vols longs ne portent que 13 % des retards — exactement leur part du trafic. La distance n'y change rien : les vols longs rattrapent jusqu'à 9 minutes en vol, et même les compagnies spécialisées ne sont pas plus en retard.</a:t>
             </a:r>
           </a:p>
         </p:txBody>

</xml_diff>

<commit_message>
Nettoyer le notebook : structure, accents francais, code en anglais
- hierarchie des titres normalisee (12 sections niveau 2, sous-sections
  niveau 3) et sommaire ajoute en tete de notebook
- accents francais retablis dans tout le texte : markdown, commentaires,
  chaines d'affichage, titres de figures (regenerees)
- identifiants Python renommes en anglais (~140 variables, fonctions,
  classes) ; noms de colonnes et cles d'exports inchanges (contrat de
  donnees avec les dashboards et CSV)
- verification : re-execution complete, resume_v2.json et les 14 CSV
  strictement identiques a l'avant-refactor (accents mis a part)
- dashboard v2 synchronise (noms de fenetres accentues), capture de la
  slide 5 rafraichie

Co-Authored-By: Claude Fable 5 <noreply@anthropic.com>
</commit_message>
<xml_diff>
--- a/rendu_presentation_v2.pptx
+++ b/rendu_presentation_v2.pptx
@@ -6062,14 +6062,14 @@
       </p:sp>
       <p:pic>
         <p:nvPicPr>
-          <p:cNvPr id="8" name="Picture 7" descr="capture_dashboard_v2_commit.png"/>
+          <p:cNvPr id="8" name="Picture 7" descr="capture_finale_accents.png"/>
           <p:cNvPicPr>
             <a:picLocks noChangeAspect="1"/>
           </p:cNvPicPr>
           <p:nvPr/>
         </p:nvPicPr>
         <p:blipFill>
-          <a:blip r:embed="rId6"/>
+          <a:blip r:embed="rId3"/>
           <a:stretch>
             <a:fillRect/>
           </a:stretch>

</xml_diff>

<commit_message>
Refondre les slides dataset/traitements et fiabiliser le dashboard
- slides 2-3 : extrait reel de flights.csv, colonnes cles expliquees,
  pipeline de traitements en 3 etapes (retour du prof en cours)
- dashboard : tuiles de la carte reecrites (surrisque x2,6 et effet
  hiver affiches), 14 compagnies etiquetees sur le nuage, legendes du
  graphique hebdomadaire explicites, titres des deux tables de routes
  clarifies (les plus annulees / les plus risquees)
- alignement methodologique : le classement des routes risquees vient
  desormais du notebook (seuil 365 vols justifie), la carte trace aussi
  ces routes ; plus aucun seuil ni chiffre code en dur dans le JS
- audit : definition exacte du retard (>= 15 min), perimetre hors
  octobre affiche, fleches typographiques
- notebook re-execute, exports et capture de la slide 5 regeneres

Co-Authored-By: Claude Fable 5 <noreply@anthropic.com>
</commit_message>
<xml_diff>
--- a/rendu_presentation_v2.pptx
+++ b/rendu_presentation_v2.pptx
@@ -3468,7 +3468,7 @@
       </p:grpSpPr>
       <p:sp>
         <p:nvSpPr>
-          <p:cNvPr id="2" name="Rectangle 1"/>
+          <p:cNvPr id="35" name="Rectangle 34"/>
           <p:cNvSpPr/>
           <p:nvPr/>
         </p:nvSpPr>
@@ -3507,13 +3507,12 @@
           <a:lstStyle/>
           <a:p>
             <a:pPr algn="ctr"/>
-            <a:endParaRPr/>
-          </a:p>
-        </p:txBody>
-      </p:sp>
-      <p:sp>
-        <p:nvSpPr>
-          <p:cNvPr id="3" name="Rectangle 2"/>
+          </a:p>
+        </p:txBody>
+      </p:sp>
+      <p:sp>
+        <p:nvSpPr>
+          <p:cNvPr id="36" name="Rectangle 35"/>
           <p:cNvSpPr/>
           <p:nvPr/>
         </p:nvSpPr>
@@ -3552,7 +3551,6 @@
           <a:lstStyle/>
           <a:p>
             <a:pPr algn="ctr"/>
-            <a:endParaRPr/>
           </a:p>
         </p:txBody>
       </p:sp>
@@ -3636,279 +3634,14 @@
       </p:sp>
       <p:sp>
         <p:nvSpPr>
-          <p:cNvPr id="6" name="TextBox 5"/>
+          <p:cNvPr id="27" name="TextBox 26"/>
           <p:cNvSpPr txBox="1"/>
           <p:nvPr/>
         </p:nvSpPr>
         <p:spPr>
           <a:xfrm>
-            <a:off x="502920" y="1691640"/>
-            <a:ext cx="11155680" cy="2103120"/>
-          </a:xfrm>
-          <a:prstGeom prst="rect">
-            <a:avLst/>
-          </a:prstGeom>
-          <a:noFill/>
-        </p:spPr>
-        <p:txBody>
-          <a:bodyPr wrap="square" anchor="t">
-            <a:spAutoFit/>
-          </a:bodyPr>
-          <a:lstStyle/>
-          <a:p>
-            <a:pPr algn="l">
-              <a:lnSpc>
-                <a:spcPct val="112000"/>
-              </a:lnSpc>
-              <a:spcAft>
-                <a:spcPts val="1000"/>
-              </a:spcAft>
-            </a:pPr>
-            <a:r>
-              <a:rPr sz="1700" b="1" i="0">
-                <a:solidFill>
-                  <a:srgbClr val="0C8792"/>
-                </a:solidFill>
-                <a:latin typeface="Calibri"/>
-              </a:rPr>
-              <a:t>▪  </a:t>
-            </a:r>
-            <a:r>
-              <a:rPr sz="1700" b="1" i="0">
-                <a:solidFill>
-                  <a:srgbClr val="142128"/>
-                </a:solidFill>
-                <a:latin typeface="Calibri"/>
-              </a:rPr>
-              <a:t>Source officielle</a:t>
-            </a:r>
-            <a:r>
-              <a:rPr sz="1700" b="0" i="0">
-                <a:solidFill>
-                  <a:srgbClr val="142128"/>
-                </a:solidFill>
-                <a:latin typeface="Calibri"/>
-              </a:rPr>
-              <a:t> — « 2015 Flight Delays and Cancellations » (Kaggle), publié par le ministère américain des Transports (US DOT)</a:t>
-            </a:r>
-          </a:p>
-          <a:p>
-            <a:pPr algn="l">
-              <a:lnSpc>
-                <a:spcPct val="112000"/>
-              </a:lnSpc>
-              <a:spcAft>
-                <a:spcPts val="1000"/>
-              </a:spcAft>
-            </a:pPr>
-            <a:r>
-              <a:rPr sz="1700" b="1" i="0">
-                <a:solidFill>
-                  <a:srgbClr val="0C8792"/>
-                </a:solidFill>
-                <a:latin typeface="Calibri"/>
-              </a:rPr>
-              <a:t>▪  </a:t>
-            </a:r>
-            <a:r>
-              <a:rPr sz="1700" b="1" i="0">
-                <a:solidFill>
-                  <a:srgbClr val="142128"/>
-                </a:solidFill>
-                <a:latin typeface="Calibri"/>
-              </a:rPr>
-              <a:t>Périmètre</a:t>
-            </a:r>
-            <a:r>
-              <a:rPr sz="1700" b="0" i="0">
-                <a:solidFill>
-                  <a:srgbClr val="142128"/>
-                </a:solidFill>
-                <a:latin typeface="Calibri"/>
-              </a:rPr>
-              <a:t> — tous les vols intérieurs américains de l'année 2015, 12 mois complets</a:t>
-            </a:r>
-          </a:p>
-          <a:p>
-            <a:pPr algn="l">
-              <a:lnSpc>
-                <a:spcPct val="112000"/>
-              </a:lnSpc>
-              <a:spcAft>
-                <a:spcPts val="1000"/>
-              </a:spcAft>
-            </a:pPr>
-            <a:r>
-              <a:rPr sz="1700" b="1" i="0">
-                <a:solidFill>
-                  <a:srgbClr val="0C8792"/>
-                </a:solidFill>
-                <a:latin typeface="Calibri"/>
-              </a:rPr>
-              <a:t>▪  </a:t>
-            </a:r>
-            <a:r>
-              <a:rPr sz="1700" b="1" i="0">
-                <a:solidFill>
-                  <a:srgbClr val="142128"/>
-                </a:solidFill>
-                <a:latin typeface="Calibri"/>
-              </a:rPr>
-              <a:t>Une ligne = un vol programmé</a:t>
-            </a:r>
-            <a:r>
-              <a:rPr sz="1700" b="0" i="0">
-                <a:solidFill>
-                  <a:srgbClr val="142128"/>
-                </a:solidFill>
-                <a:latin typeface="Calibri"/>
-              </a:rPr>
-              <a:t> — date, compagnie, aéroports de départ et d'arrivée, horaires, retard, annulation et son motif</a:t>
-            </a:r>
-          </a:p>
-          <a:p>
-            <a:pPr algn="l">
-              <a:lnSpc>
-                <a:spcPct val="112000"/>
-              </a:lnSpc>
-              <a:spcAft>
-                <a:spcPts val="1000"/>
-              </a:spcAft>
-            </a:pPr>
-            <a:r>
-              <a:rPr sz="1700" b="1" i="0">
-                <a:solidFill>
-                  <a:srgbClr val="0C8792"/>
-                </a:solidFill>
-                <a:latin typeface="Calibri"/>
-              </a:rPr>
-              <a:t>▪  </a:t>
-            </a:r>
-            <a:r>
-              <a:rPr sz="1700" b="1" i="0">
-                <a:solidFill>
-                  <a:srgbClr val="142128"/>
-                </a:solidFill>
-                <a:latin typeface="Calibri"/>
-              </a:rPr>
-              <a:t>Trois fichiers croisés</a:t>
-            </a:r>
-            <a:r>
-              <a:rPr sz="1700" b="0" i="0">
-                <a:solidFill>
-                  <a:srgbClr val="142128"/>
-                </a:solidFill>
-                <a:latin typeface="Calibri"/>
-              </a:rPr>
-              <a:t> — les vols (592 Mo), l'annuaire des 14 compagnies, les 322 aéroports avec leurs coordonnées (pour la carte)</a:t>
-            </a:r>
-          </a:p>
-        </p:txBody>
-      </p:sp>
-      <p:sp>
-        <p:nvSpPr>
-          <p:cNvPr id="7" name="Rounded Rectangle 6"/>
-          <p:cNvSpPr/>
-          <p:nvPr/>
-        </p:nvSpPr>
-        <p:spPr>
-          <a:xfrm>
-            <a:off x="502920" y="4160520"/>
-            <a:ext cx="2615184" cy="1417320"/>
-          </a:xfrm>
-          <a:prstGeom prst="roundRect">
-            <a:avLst>
-              <a:gd name="adj" fmla="val 8000"/>
-            </a:avLst>
-          </a:prstGeom>
-          <a:solidFill>
-            <a:srgbClr val="FFFFFF"/>
-          </a:solidFill>
-          <a:ln w="12700">
-            <a:solidFill>
-              <a:srgbClr val="DCE5E8"/>
-            </a:solidFill>
-          </a:ln>
-          <a:effectLst/>
-        </p:spPr>
-        <p:style>
-          <a:lnRef idx="1">
-            <a:schemeClr val="accent1"/>
-          </a:lnRef>
-          <a:fillRef idx="3">
-            <a:schemeClr val="accent1"/>
-          </a:fillRef>
-          <a:effectRef idx="2">
-            <a:schemeClr val="accent1"/>
-          </a:effectRef>
-          <a:fontRef idx="minor">
-            <a:schemeClr val="lt1"/>
-          </a:fontRef>
-        </p:style>
-        <p:txBody>
-          <a:bodyPr rtlCol="0" anchor="ctr"/>
-          <a:lstStyle/>
-          <a:p>
-            <a:pPr algn="ctr"/>
-            <a:endParaRPr/>
-          </a:p>
-        </p:txBody>
-      </p:sp>
-      <p:sp>
-        <p:nvSpPr>
-          <p:cNvPr id="8" name="Rectangle 7"/>
-          <p:cNvSpPr/>
-          <p:nvPr/>
-        </p:nvSpPr>
-        <p:spPr>
-          <a:xfrm>
-            <a:off x="502920" y="4270248"/>
-            <a:ext cx="50292" cy="1197864"/>
-          </a:xfrm>
-          <a:prstGeom prst="rect">
-            <a:avLst/>
-          </a:prstGeom>
-          <a:solidFill>
-            <a:srgbClr val="0C8792"/>
-          </a:solidFill>
-          <a:ln>
-            <a:noFill/>
-          </a:ln>
-          <a:effectLst/>
-        </p:spPr>
-        <p:style>
-          <a:lnRef idx="1">
-            <a:schemeClr val="accent1"/>
-          </a:lnRef>
-          <a:fillRef idx="3">
-            <a:schemeClr val="accent1"/>
-          </a:fillRef>
-          <a:effectRef idx="2">
-            <a:schemeClr val="accent1"/>
-          </a:effectRef>
-          <a:fontRef idx="minor">
-            <a:schemeClr val="lt1"/>
-          </a:fontRef>
-        </p:style>
-        <p:txBody>
-          <a:bodyPr rtlCol="0" anchor="ctr"/>
-          <a:lstStyle/>
-          <a:p>
-            <a:pPr algn="ctr"/>
-            <a:endParaRPr/>
-          </a:p>
-        </p:txBody>
-      </p:sp>
-      <p:sp>
-        <p:nvSpPr>
-          <p:cNvPr id="9" name="TextBox 8"/>
-          <p:cNvSpPr txBox="1"/>
-          <p:nvPr/>
-        </p:nvSpPr>
-        <p:spPr>
-          <a:xfrm>
-            <a:off x="704088" y="4288536"/>
-            <a:ext cx="2249424" cy="320040"/>
+            <a:off x="502920" y="6455664"/>
+            <a:ext cx="8229600" cy="320040"/>
           </a:xfrm>
           <a:prstGeom prst="rect">
             <a:avLst/>
@@ -3927,756 +3660,6 @@
               </a:spcAft>
             </a:pPr>
             <a:r>
-              <a:rPr sz="1100" b="1" i="0">
-                <a:solidFill>
-                  <a:srgbClr val="687985"/>
-                </a:solidFill>
-                <a:latin typeface="Calibri"/>
-              </a:rPr>
-              <a:t>VOLS ANALYSÉS</a:t>
-            </a:r>
-          </a:p>
-        </p:txBody>
-      </p:sp>
-      <p:sp>
-        <p:nvSpPr>
-          <p:cNvPr id="10" name="TextBox 9"/>
-          <p:cNvSpPr txBox="1"/>
-          <p:nvPr/>
-        </p:nvSpPr>
-        <p:spPr>
-          <a:xfrm>
-            <a:off x="704088" y="4562856"/>
-            <a:ext cx="2249424" cy="502920"/>
-          </a:xfrm>
-          <a:prstGeom prst="rect">
-            <a:avLst/>
-          </a:prstGeom>
-          <a:noFill/>
-        </p:spPr>
-        <p:txBody>
-          <a:bodyPr wrap="square" anchor="t">
-            <a:spAutoFit/>
-          </a:bodyPr>
-          <a:lstStyle/>
-          <a:p>
-            <a:pPr algn="l">
-              <a:spcAft>
-                <a:spcPts val="600"/>
-              </a:spcAft>
-            </a:pPr>
-            <a:r>
-              <a:rPr sz="2700" b="1" i="0">
-                <a:solidFill>
-                  <a:srgbClr val="142128"/>
-                </a:solidFill>
-                <a:latin typeface="Calibri"/>
-              </a:rPr>
-              <a:t>5 819 079</a:t>
-            </a:r>
-          </a:p>
-        </p:txBody>
-      </p:sp>
-      <p:sp>
-        <p:nvSpPr>
-          <p:cNvPr id="11" name="TextBox 10"/>
-          <p:cNvSpPr txBox="1"/>
-          <p:nvPr/>
-        </p:nvSpPr>
-        <p:spPr>
-          <a:xfrm>
-            <a:off x="704088" y="5193792"/>
-            <a:ext cx="2249424" cy="320040"/>
-          </a:xfrm>
-          <a:prstGeom prst="rect">
-            <a:avLst/>
-          </a:prstGeom>
-          <a:noFill/>
-        </p:spPr>
-        <p:txBody>
-          <a:bodyPr wrap="square" anchor="t">
-            <a:spAutoFit/>
-          </a:bodyPr>
-          <a:lstStyle/>
-          <a:p>
-            <a:pPr algn="l">
-              <a:spcAft>
-                <a:spcPts val="600"/>
-              </a:spcAft>
-            </a:pPr>
-            <a:r>
-              <a:rPr sz="1100" b="0" i="0">
-                <a:solidFill>
-                  <a:srgbClr val="687985"/>
-                </a:solidFill>
-                <a:latin typeface="Calibri"/>
-              </a:rPr>
-              <a:t>année 2015 complète</a:t>
-            </a:r>
-          </a:p>
-        </p:txBody>
-      </p:sp>
-      <p:sp>
-        <p:nvSpPr>
-          <p:cNvPr id="12" name="Rounded Rectangle 11"/>
-          <p:cNvSpPr/>
-          <p:nvPr/>
-        </p:nvSpPr>
-        <p:spPr>
-          <a:xfrm>
-            <a:off x="3346704" y="4160520"/>
-            <a:ext cx="2615184" cy="1417320"/>
-          </a:xfrm>
-          <a:prstGeom prst="roundRect">
-            <a:avLst>
-              <a:gd name="adj" fmla="val 8000"/>
-            </a:avLst>
-          </a:prstGeom>
-          <a:solidFill>
-            <a:srgbClr val="FFFFFF"/>
-          </a:solidFill>
-          <a:ln w="12700">
-            <a:solidFill>
-              <a:srgbClr val="DCE5E8"/>
-            </a:solidFill>
-          </a:ln>
-          <a:effectLst/>
-        </p:spPr>
-        <p:style>
-          <a:lnRef idx="1">
-            <a:schemeClr val="accent1"/>
-          </a:lnRef>
-          <a:fillRef idx="3">
-            <a:schemeClr val="accent1"/>
-          </a:fillRef>
-          <a:effectRef idx="2">
-            <a:schemeClr val="accent1"/>
-          </a:effectRef>
-          <a:fontRef idx="minor">
-            <a:schemeClr val="lt1"/>
-          </a:fontRef>
-        </p:style>
-        <p:txBody>
-          <a:bodyPr rtlCol="0" anchor="ctr"/>
-          <a:lstStyle/>
-          <a:p>
-            <a:pPr algn="ctr"/>
-            <a:endParaRPr/>
-          </a:p>
-        </p:txBody>
-      </p:sp>
-      <p:sp>
-        <p:nvSpPr>
-          <p:cNvPr id="13" name="Rectangle 12"/>
-          <p:cNvSpPr/>
-          <p:nvPr/>
-        </p:nvSpPr>
-        <p:spPr>
-          <a:xfrm>
-            <a:off x="3346704" y="4270248"/>
-            <a:ext cx="50292" cy="1197864"/>
-          </a:xfrm>
-          <a:prstGeom prst="rect">
-            <a:avLst/>
-          </a:prstGeom>
-          <a:solidFill>
-            <a:srgbClr val="0C8792"/>
-          </a:solidFill>
-          <a:ln>
-            <a:noFill/>
-          </a:ln>
-          <a:effectLst/>
-        </p:spPr>
-        <p:style>
-          <a:lnRef idx="1">
-            <a:schemeClr val="accent1"/>
-          </a:lnRef>
-          <a:fillRef idx="3">
-            <a:schemeClr val="accent1"/>
-          </a:fillRef>
-          <a:effectRef idx="2">
-            <a:schemeClr val="accent1"/>
-          </a:effectRef>
-          <a:fontRef idx="minor">
-            <a:schemeClr val="lt1"/>
-          </a:fontRef>
-        </p:style>
-        <p:txBody>
-          <a:bodyPr rtlCol="0" anchor="ctr"/>
-          <a:lstStyle/>
-          <a:p>
-            <a:pPr algn="ctr"/>
-            <a:endParaRPr/>
-          </a:p>
-        </p:txBody>
-      </p:sp>
-      <p:sp>
-        <p:nvSpPr>
-          <p:cNvPr id="14" name="TextBox 13"/>
-          <p:cNvSpPr txBox="1"/>
-          <p:nvPr/>
-        </p:nvSpPr>
-        <p:spPr>
-          <a:xfrm>
-            <a:off x="3547872" y="4288536"/>
-            <a:ext cx="2249424" cy="320040"/>
-          </a:xfrm>
-          <a:prstGeom prst="rect">
-            <a:avLst/>
-          </a:prstGeom>
-          <a:noFill/>
-        </p:spPr>
-        <p:txBody>
-          <a:bodyPr wrap="square" anchor="t">
-            <a:spAutoFit/>
-          </a:bodyPr>
-          <a:lstStyle/>
-          <a:p>
-            <a:pPr algn="l">
-              <a:spcAft>
-                <a:spcPts val="600"/>
-              </a:spcAft>
-            </a:pPr>
-            <a:r>
-              <a:rPr sz="1100" b="1" i="0">
-                <a:solidFill>
-                  <a:srgbClr val="687985"/>
-                </a:solidFill>
-                <a:latin typeface="Calibri"/>
-              </a:rPr>
-              <a:t>COMPAGNIES</a:t>
-            </a:r>
-          </a:p>
-        </p:txBody>
-      </p:sp>
-      <p:sp>
-        <p:nvSpPr>
-          <p:cNvPr id="15" name="TextBox 14"/>
-          <p:cNvSpPr txBox="1"/>
-          <p:nvPr/>
-        </p:nvSpPr>
-        <p:spPr>
-          <a:xfrm>
-            <a:off x="3547872" y="4562856"/>
-            <a:ext cx="2249424" cy="502920"/>
-          </a:xfrm>
-          <a:prstGeom prst="rect">
-            <a:avLst/>
-          </a:prstGeom>
-          <a:noFill/>
-        </p:spPr>
-        <p:txBody>
-          <a:bodyPr wrap="square" anchor="t">
-            <a:spAutoFit/>
-          </a:bodyPr>
-          <a:lstStyle/>
-          <a:p>
-            <a:pPr algn="l">
-              <a:spcAft>
-                <a:spcPts val="600"/>
-              </a:spcAft>
-            </a:pPr>
-            <a:r>
-              <a:rPr sz="2700" b="1" i="0">
-                <a:solidFill>
-                  <a:srgbClr val="142128"/>
-                </a:solidFill>
-                <a:latin typeface="Calibri"/>
-              </a:rPr>
-              <a:t>14</a:t>
-            </a:r>
-          </a:p>
-        </p:txBody>
-      </p:sp>
-      <p:sp>
-        <p:nvSpPr>
-          <p:cNvPr id="16" name="TextBox 15"/>
-          <p:cNvSpPr txBox="1"/>
-          <p:nvPr/>
-        </p:nvSpPr>
-        <p:spPr>
-          <a:xfrm>
-            <a:off x="3547872" y="5193792"/>
-            <a:ext cx="2249424" cy="320040"/>
-          </a:xfrm>
-          <a:prstGeom prst="rect">
-            <a:avLst/>
-          </a:prstGeom>
-          <a:noFill/>
-        </p:spPr>
-        <p:txBody>
-          <a:bodyPr wrap="square" anchor="t">
-            <a:spAutoFit/>
-          </a:bodyPr>
-          <a:lstStyle/>
-          <a:p>
-            <a:pPr algn="l">
-              <a:spcAft>
-                <a:spcPts val="600"/>
-              </a:spcAft>
-            </a:pPr>
-            <a:r>
-              <a:rPr sz="1100" b="0" i="0">
-                <a:solidFill>
-                  <a:srgbClr val="687985"/>
-                </a:solidFill>
-                <a:latin typeface="Calibri"/>
-              </a:rPr>
-              <a:t>de Delta à Spirit</a:t>
-            </a:r>
-          </a:p>
-        </p:txBody>
-      </p:sp>
-      <p:sp>
-        <p:nvSpPr>
-          <p:cNvPr id="17" name="Rounded Rectangle 16"/>
-          <p:cNvSpPr/>
-          <p:nvPr/>
-        </p:nvSpPr>
-        <p:spPr>
-          <a:xfrm>
-            <a:off x="6190488" y="4160520"/>
-            <a:ext cx="2615184" cy="1417320"/>
-          </a:xfrm>
-          <a:prstGeom prst="roundRect">
-            <a:avLst>
-              <a:gd name="adj" fmla="val 8000"/>
-            </a:avLst>
-          </a:prstGeom>
-          <a:solidFill>
-            <a:srgbClr val="FFFFFF"/>
-          </a:solidFill>
-          <a:ln w="12700">
-            <a:solidFill>
-              <a:srgbClr val="DCE5E8"/>
-            </a:solidFill>
-          </a:ln>
-          <a:effectLst/>
-        </p:spPr>
-        <p:style>
-          <a:lnRef idx="1">
-            <a:schemeClr val="accent1"/>
-          </a:lnRef>
-          <a:fillRef idx="3">
-            <a:schemeClr val="accent1"/>
-          </a:fillRef>
-          <a:effectRef idx="2">
-            <a:schemeClr val="accent1"/>
-          </a:effectRef>
-          <a:fontRef idx="minor">
-            <a:schemeClr val="lt1"/>
-          </a:fontRef>
-        </p:style>
-        <p:txBody>
-          <a:bodyPr rtlCol="0" anchor="ctr"/>
-          <a:lstStyle/>
-          <a:p>
-            <a:pPr algn="ctr"/>
-            <a:endParaRPr/>
-          </a:p>
-        </p:txBody>
-      </p:sp>
-      <p:sp>
-        <p:nvSpPr>
-          <p:cNvPr id="18" name="Rectangle 17"/>
-          <p:cNvSpPr/>
-          <p:nvPr/>
-        </p:nvSpPr>
-        <p:spPr>
-          <a:xfrm>
-            <a:off x="6190488" y="4270248"/>
-            <a:ext cx="50292" cy="1197864"/>
-          </a:xfrm>
-          <a:prstGeom prst="rect">
-            <a:avLst/>
-          </a:prstGeom>
-          <a:solidFill>
-            <a:srgbClr val="0C8792"/>
-          </a:solidFill>
-          <a:ln>
-            <a:noFill/>
-          </a:ln>
-          <a:effectLst/>
-        </p:spPr>
-        <p:style>
-          <a:lnRef idx="1">
-            <a:schemeClr val="accent1"/>
-          </a:lnRef>
-          <a:fillRef idx="3">
-            <a:schemeClr val="accent1"/>
-          </a:fillRef>
-          <a:effectRef idx="2">
-            <a:schemeClr val="accent1"/>
-          </a:effectRef>
-          <a:fontRef idx="minor">
-            <a:schemeClr val="lt1"/>
-          </a:fontRef>
-        </p:style>
-        <p:txBody>
-          <a:bodyPr rtlCol="0" anchor="ctr"/>
-          <a:lstStyle/>
-          <a:p>
-            <a:pPr algn="ctr"/>
-            <a:endParaRPr/>
-          </a:p>
-        </p:txBody>
-      </p:sp>
-      <p:sp>
-        <p:nvSpPr>
-          <p:cNvPr id="19" name="TextBox 18"/>
-          <p:cNvSpPr txBox="1"/>
-          <p:nvPr/>
-        </p:nvSpPr>
-        <p:spPr>
-          <a:xfrm>
-            <a:off x="6391656" y="4288536"/>
-            <a:ext cx="2249424" cy="320040"/>
-          </a:xfrm>
-          <a:prstGeom prst="rect">
-            <a:avLst/>
-          </a:prstGeom>
-          <a:noFill/>
-        </p:spPr>
-        <p:txBody>
-          <a:bodyPr wrap="square" anchor="t">
-            <a:spAutoFit/>
-          </a:bodyPr>
-          <a:lstStyle/>
-          <a:p>
-            <a:pPr algn="l">
-              <a:spcAft>
-                <a:spcPts val="600"/>
-              </a:spcAft>
-            </a:pPr>
-            <a:r>
-              <a:rPr sz="1100" b="1" i="0">
-                <a:solidFill>
-                  <a:srgbClr val="687985"/>
-                </a:solidFill>
-                <a:latin typeface="Calibri"/>
-              </a:rPr>
-              <a:t>AÉROPORTS</a:t>
-            </a:r>
-          </a:p>
-        </p:txBody>
-      </p:sp>
-      <p:sp>
-        <p:nvSpPr>
-          <p:cNvPr id="20" name="TextBox 19"/>
-          <p:cNvSpPr txBox="1"/>
-          <p:nvPr/>
-        </p:nvSpPr>
-        <p:spPr>
-          <a:xfrm>
-            <a:off x="6391656" y="4562856"/>
-            <a:ext cx="2249424" cy="502920"/>
-          </a:xfrm>
-          <a:prstGeom prst="rect">
-            <a:avLst/>
-          </a:prstGeom>
-          <a:noFill/>
-        </p:spPr>
-        <p:txBody>
-          <a:bodyPr wrap="square" anchor="t">
-            <a:spAutoFit/>
-          </a:bodyPr>
-          <a:lstStyle/>
-          <a:p>
-            <a:pPr algn="l">
-              <a:spcAft>
-                <a:spcPts val="600"/>
-              </a:spcAft>
-            </a:pPr>
-            <a:r>
-              <a:rPr sz="2700" b="1" i="0">
-                <a:solidFill>
-                  <a:srgbClr val="142128"/>
-                </a:solidFill>
-                <a:latin typeface="Calibri"/>
-              </a:rPr>
-              <a:t>322</a:t>
-            </a:r>
-          </a:p>
-        </p:txBody>
-      </p:sp>
-      <p:sp>
-        <p:nvSpPr>
-          <p:cNvPr id="21" name="TextBox 20"/>
-          <p:cNvSpPr txBox="1"/>
-          <p:nvPr/>
-        </p:nvSpPr>
-        <p:spPr>
-          <a:xfrm>
-            <a:off x="6391656" y="5193792"/>
-            <a:ext cx="2249424" cy="320040"/>
-          </a:xfrm>
-          <a:prstGeom prst="rect">
-            <a:avLst/>
-          </a:prstGeom>
-          <a:noFill/>
-        </p:spPr>
-        <p:txBody>
-          <a:bodyPr wrap="square" anchor="t">
-            <a:spAutoFit/>
-          </a:bodyPr>
-          <a:lstStyle/>
-          <a:p>
-            <a:pPr algn="l">
-              <a:spcAft>
-                <a:spcPts val="600"/>
-              </a:spcAft>
-            </a:pPr>
-            <a:r>
-              <a:rPr sz="1100" b="0" i="0">
-                <a:solidFill>
-                  <a:srgbClr val="687985"/>
-                </a:solidFill>
-                <a:latin typeface="Calibri"/>
-              </a:rPr>
-              <a:t>4 693 liaisons directes</a:t>
-            </a:r>
-          </a:p>
-        </p:txBody>
-      </p:sp>
-      <p:sp>
-        <p:nvSpPr>
-          <p:cNvPr id="22" name="Rounded Rectangle 21"/>
-          <p:cNvSpPr/>
-          <p:nvPr/>
-        </p:nvSpPr>
-        <p:spPr>
-          <a:xfrm>
-            <a:off x="9034272" y="4160520"/>
-            <a:ext cx="2615184" cy="1417320"/>
-          </a:xfrm>
-          <a:prstGeom prst="roundRect">
-            <a:avLst>
-              <a:gd name="adj" fmla="val 8000"/>
-            </a:avLst>
-          </a:prstGeom>
-          <a:solidFill>
-            <a:srgbClr val="FFFFFF"/>
-          </a:solidFill>
-          <a:ln w="12700">
-            <a:solidFill>
-              <a:srgbClr val="DCE5E8"/>
-            </a:solidFill>
-          </a:ln>
-          <a:effectLst/>
-        </p:spPr>
-        <p:style>
-          <a:lnRef idx="1">
-            <a:schemeClr val="accent1"/>
-          </a:lnRef>
-          <a:fillRef idx="3">
-            <a:schemeClr val="accent1"/>
-          </a:fillRef>
-          <a:effectRef idx="2">
-            <a:schemeClr val="accent1"/>
-          </a:effectRef>
-          <a:fontRef idx="minor">
-            <a:schemeClr val="lt1"/>
-          </a:fontRef>
-        </p:style>
-        <p:txBody>
-          <a:bodyPr rtlCol="0" anchor="ctr"/>
-          <a:lstStyle/>
-          <a:p>
-            <a:pPr algn="ctr"/>
-            <a:endParaRPr/>
-          </a:p>
-        </p:txBody>
-      </p:sp>
-      <p:sp>
-        <p:nvSpPr>
-          <p:cNvPr id="23" name="Rectangle 22"/>
-          <p:cNvSpPr/>
-          <p:nvPr/>
-        </p:nvSpPr>
-        <p:spPr>
-          <a:xfrm>
-            <a:off x="9034272" y="4270248"/>
-            <a:ext cx="50292" cy="1197864"/>
-          </a:xfrm>
-          <a:prstGeom prst="rect">
-            <a:avLst/>
-          </a:prstGeom>
-          <a:solidFill>
-            <a:srgbClr val="EB5A3C"/>
-          </a:solidFill>
-          <a:ln>
-            <a:noFill/>
-          </a:ln>
-          <a:effectLst/>
-        </p:spPr>
-        <p:style>
-          <a:lnRef idx="1">
-            <a:schemeClr val="accent1"/>
-          </a:lnRef>
-          <a:fillRef idx="3">
-            <a:schemeClr val="accent1"/>
-          </a:fillRef>
-          <a:effectRef idx="2">
-            <a:schemeClr val="accent1"/>
-          </a:effectRef>
-          <a:fontRef idx="minor">
-            <a:schemeClr val="lt1"/>
-          </a:fontRef>
-        </p:style>
-        <p:txBody>
-          <a:bodyPr rtlCol="0" anchor="ctr"/>
-          <a:lstStyle/>
-          <a:p>
-            <a:pPr algn="ctr"/>
-            <a:endParaRPr/>
-          </a:p>
-        </p:txBody>
-      </p:sp>
-      <p:sp>
-        <p:nvSpPr>
-          <p:cNvPr id="24" name="TextBox 23"/>
-          <p:cNvSpPr txBox="1"/>
-          <p:nvPr/>
-        </p:nvSpPr>
-        <p:spPr>
-          <a:xfrm>
-            <a:off x="9235440" y="4288536"/>
-            <a:ext cx="2249424" cy="320040"/>
-          </a:xfrm>
-          <a:prstGeom prst="rect">
-            <a:avLst/>
-          </a:prstGeom>
-          <a:noFill/>
-        </p:spPr>
-        <p:txBody>
-          <a:bodyPr wrap="square" anchor="t">
-            <a:spAutoFit/>
-          </a:bodyPr>
-          <a:lstStyle/>
-          <a:p>
-            <a:pPr algn="l">
-              <a:spcAft>
-                <a:spcPts val="600"/>
-              </a:spcAft>
-            </a:pPr>
-            <a:r>
-              <a:rPr sz="1100" b="1" i="0">
-                <a:solidFill>
-                  <a:srgbClr val="687985"/>
-                </a:solidFill>
-                <a:latin typeface="Calibri"/>
-              </a:rPr>
-              <a:t>VOLS EN RETARD</a:t>
-            </a:r>
-          </a:p>
-        </p:txBody>
-      </p:sp>
-      <p:sp>
-        <p:nvSpPr>
-          <p:cNvPr id="25" name="TextBox 24"/>
-          <p:cNvSpPr txBox="1"/>
-          <p:nvPr/>
-        </p:nvSpPr>
-        <p:spPr>
-          <a:xfrm>
-            <a:off x="9235440" y="4562856"/>
-            <a:ext cx="2249424" cy="502920"/>
-          </a:xfrm>
-          <a:prstGeom prst="rect">
-            <a:avLst/>
-          </a:prstGeom>
-          <a:noFill/>
-        </p:spPr>
-        <p:txBody>
-          <a:bodyPr wrap="square" anchor="t">
-            <a:spAutoFit/>
-          </a:bodyPr>
-          <a:lstStyle/>
-          <a:p>
-            <a:pPr algn="l">
-              <a:spcAft>
-                <a:spcPts val="600"/>
-              </a:spcAft>
-            </a:pPr>
-            <a:r>
-              <a:rPr sz="2700" b="1" i="0">
-                <a:solidFill>
-                  <a:srgbClr val="142128"/>
-                </a:solidFill>
-                <a:latin typeface="Calibri"/>
-              </a:rPr>
-              <a:t>18,6 %</a:t>
-            </a:r>
-          </a:p>
-        </p:txBody>
-      </p:sp>
-      <p:sp>
-        <p:nvSpPr>
-          <p:cNvPr id="26" name="TextBox 25"/>
-          <p:cNvSpPr txBox="1"/>
-          <p:nvPr/>
-        </p:nvSpPr>
-        <p:spPr>
-          <a:xfrm>
-            <a:off x="9235440" y="5193792"/>
-            <a:ext cx="2249424" cy="320040"/>
-          </a:xfrm>
-          <a:prstGeom prst="rect">
-            <a:avLst/>
-          </a:prstGeom>
-          <a:noFill/>
-        </p:spPr>
-        <p:txBody>
-          <a:bodyPr wrap="square" anchor="t">
-            <a:spAutoFit/>
-          </a:bodyPr>
-          <a:lstStyle/>
-          <a:p>
-            <a:pPr algn="l">
-              <a:spcAft>
-                <a:spcPts val="600"/>
-              </a:spcAft>
-            </a:pPr>
-            <a:r>
-              <a:rPr sz="1100" b="0" i="0">
-                <a:solidFill>
-                  <a:srgbClr val="687985"/>
-                </a:solidFill>
-                <a:latin typeface="Calibri"/>
-              </a:rPr>
-              <a:t>1,5 % de vols annulés</a:t>
-            </a:r>
-          </a:p>
-        </p:txBody>
-      </p:sp>
-      <p:sp>
-        <p:nvSpPr>
-          <p:cNvPr id="27" name="TextBox 26"/>
-          <p:cNvSpPr txBox="1"/>
-          <p:nvPr/>
-        </p:nvSpPr>
-        <p:spPr>
-          <a:xfrm>
-            <a:off x="502920" y="6455664"/>
-            <a:ext cx="8229600" cy="320040"/>
-          </a:xfrm>
-          <a:prstGeom prst="rect">
-            <a:avLst/>
-          </a:prstGeom>
-          <a:noFill/>
-        </p:spPr>
-        <p:txBody>
-          <a:bodyPr wrap="square" anchor="t">
-            <a:spAutoFit/>
-          </a:bodyPr>
-          <a:lstStyle/>
-          <a:p>
-            <a:pPr algn="l">
-              <a:spcAft>
-                <a:spcPts val="600"/>
-              </a:spcAft>
-            </a:pPr>
-            <a:r>
               <a:rPr sz="1000" b="0" i="0">
                 <a:solidFill>
                   <a:srgbClr val="687985"/>
@@ -4723,6 +3706,1463 @@
                 <a:latin typeface="Calibri"/>
               </a:rPr>
               <a:t>2</a:t>
+            </a:r>
+          </a:p>
+        </p:txBody>
+      </p:sp>
+      <p:sp>
+        <p:nvSpPr>
+          <p:cNvPr id="29" name="TextBox 28"/>
+          <p:cNvSpPr txBox="1"/>
+          <p:nvPr/>
+        </p:nvSpPr>
+        <p:spPr>
+          <a:xfrm>
+            <a:off x="502920" y="1207008"/>
+            <a:ext cx="11155680" cy="1170432"/>
+          </a:xfrm>
+          <a:prstGeom prst="rect">
+            <a:avLst/>
+          </a:prstGeom>
+          <a:noFill/>
+        </p:spPr>
+        <p:txBody>
+          <a:bodyPr wrap="square" anchor="t">
+            <a:spAutoFit/>
+          </a:bodyPr>
+          <a:lstStyle/>
+          <a:p>
+            <a:pPr algn="l">
+              <a:spcAft>
+                <a:spcPts val="300"/>
+              </a:spcAft>
+            </a:pPr>
+            <a:r>
+              <a:rPr sz="1350" b="1">
+                <a:solidFill>
+                  <a:srgbClr val="0C8792"/>
+                </a:solidFill>
+                <a:latin typeface="Calibri"/>
+              </a:rPr>
+              <a:t>▪  </a:t>
+            </a:r>
+            <a:r>
+              <a:rPr sz="1350" b="1">
+                <a:solidFill>
+                  <a:srgbClr val="142128"/>
+                </a:solidFill>
+                <a:latin typeface="Calibri"/>
+              </a:rPr>
+              <a:t>Recense tous les vols intérieurs américains de l'année 2015</a:t>
+            </a:r>
+            <a:r>
+              <a:rPr sz="1350" b="0">
+                <a:solidFill>
+                  <a:srgbClr val="142128"/>
+                </a:solidFill>
+                <a:latin typeface="Calibri"/>
+              </a:rPr>
+              <a:t> — 5 819 079 enregistrements, 31 colonnes</a:t>
+            </a:r>
+          </a:p>
+          <a:p>
+            <a:pPr algn="l">
+              <a:spcAft>
+                <a:spcPts val="300"/>
+              </a:spcAft>
+            </a:pPr>
+            <a:r>
+              <a:rPr sz="1350" b="1">
+                <a:solidFill>
+                  <a:srgbClr val="0C8792"/>
+                </a:solidFill>
+                <a:latin typeface="Calibri"/>
+              </a:rPr>
+              <a:t>▪  </a:t>
+            </a:r>
+            <a:r>
+              <a:rPr sz="1350" b="1">
+                <a:solidFill>
+                  <a:srgbClr val="142128"/>
+                </a:solidFill>
+                <a:latin typeface="Calibri"/>
+              </a:rPr>
+              <a:t>Trois fichiers croisés</a:t>
+            </a:r>
+            <a:r>
+              <a:rPr sz="1350" b="0">
+                <a:solidFill>
+                  <a:srgbClr val="142128"/>
+                </a:solidFill>
+                <a:latin typeface="Calibri"/>
+              </a:rPr>
+              <a:t> : les vols, l'annuaire des 14 compagnies, les 322 aéroports avec coordonnées</a:t>
+            </a:r>
+          </a:p>
+          <a:p>
+            <a:pPr algn="l">
+              <a:spcAft>
+                <a:spcPts val="300"/>
+              </a:spcAft>
+            </a:pPr>
+            <a:r>
+              <a:rPr sz="1350" b="1">
+                <a:solidFill>
+                  <a:srgbClr val="0C8792"/>
+                </a:solidFill>
+                <a:latin typeface="Calibri"/>
+              </a:rPr>
+              <a:t>▪  </a:t>
+            </a:r>
+            <a:r>
+              <a:rPr sz="1350" b="1">
+                <a:solidFill>
+                  <a:srgbClr val="142128"/>
+                </a:solidFill>
+                <a:latin typeface="Calibri"/>
+              </a:rPr>
+              <a:t>Une ligne = un vol programmé</a:t>
+            </a:r>
+            <a:r>
+              <a:rPr sz="1350" b="0">
+                <a:solidFill>
+                  <a:srgbClr val="142128"/>
+                </a:solidFill>
+                <a:latin typeface="Calibri"/>
+              </a:rPr>
+              <a:t> : date, compagnie, aéroports, horaires, retard, annulation et motif</a:t>
+            </a:r>
+          </a:p>
+          <a:p>
+            <a:pPr algn="l">
+              <a:spcAft>
+                <a:spcPts val="300"/>
+              </a:spcAft>
+            </a:pPr>
+            <a:r>
+              <a:rPr sz="1350" b="1">
+                <a:solidFill>
+                  <a:srgbClr val="0C8792"/>
+                </a:solidFill>
+                <a:latin typeface="Calibri"/>
+              </a:rPr>
+              <a:t>▪  </a:t>
+            </a:r>
+            <a:r>
+              <a:rPr sz="1350" b="1">
+                <a:solidFill>
+                  <a:srgbClr val="142128"/>
+                </a:solidFill>
+                <a:latin typeface="Calibri"/>
+              </a:rPr>
+              <a:t>Source</a:t>
+            </a:r>
+            <a:r>
+              <a:rPr sz="1350" b="0">
+                <a:solidFill>
+                  <a:srgbClr val="142128"/>
+                </a:solidFill>
+                <a:latin typeface="Calibri"/>
+              </a:rPr>
+              <a:t> : Kaggle / U.S. DOT — kaggle.com/datasets/usdot/flight-delays</a:t>
+            </a:r>
+          </a:p>
+        </p:txBody>
+      </p:sp>
+      <p:sp>
+        <p:nvSpPr>
+          <p:cNvPr id="30" name="TextBox 29"/>
+          <p:cNvSpPr txBox="1"/>
+          <p:nvPr/>
+        </p:nvSpPr>
+        <p:spPr>
+          <a:xfrm>
+            <a:off x="502920" y="2432304"/>
+            <a:ext cx="11155680" cy="274320"/>
+          </a:xfrm>
+          <a:prstGeom prst="rect">
+            <a:avLst/>
+          </a:prstGeom>
+          <a:noFill/>
+        </p:spPr>
+        <p:txBody>
+          <a:bodyPr wrap="square" anchor="t">
+            <a:spAutoFit/>
+          </a:bodyPr>
+          <a:lstStyle/>
+          <a:p>
+            <a:pPr algn="l">
+              <a:spcAft>
+                <a:spcPts val="400"/>
+              </a:spcAft>
+            </a:pPr>
+            <a:r>
+              <a:rPr sz="1200" b="1">
+                <a:solidFill>
+                  <a:srgbClr val="687985"/>
+                </a:solidFill>
+                <a:latin typeface="Calibri"/>
+              </a:rPr>
+              <a:t>Extrait du fichier des vols (données réelles) :</a:t>
+            </a:r>
+          </a:p>
+        </p:txBody>
+      </p:sp>
+      <p:graphicFrame>
+        <p:nvGraphicFramePr>
+          <p:cNvPr id="31" name="Table 30"/>
+          <p:cNvGraphicFramePr>
+            <a:graphicFrameLocks noGrp="1"/>
+          </p:cNvGraphicFramePr>
+          <p:nvPr/>
+        </p:nvGraphicFramePr>
+        <p:xfrm>
+          <a:off x="502920" y="2724912"/>
+          <a:ext cx="11155680" cy="1508760"/>
+        </p:xfrm>
+        <a:graphic>
+          <a:graphicData uri="http://schemas.openxmlformats.org/drawingml/2006/table">
+            <a:tbl>
+              <a:tblPr firstRow="1" bandRow="1">
+                <a:tableStyleId>{5C22544A-7EE6-4342-B048-85BDC9FD1C3A}</a:tableStyleId>
+              </a:tblPr>
+              <a:tblGrid>
+                <a:gridCol w="1234440"/>
+                <a:gridCol w="1051560"/>
+                <a:gridCol w="1508760"/>
+                <a:gridCol w="1783080"/>
+                <a:gridCol w="1143000"/>
+                <a:gridCol w="1508760"/>
+                <a:gridCol w="1234440"/>
+                <a:gridCol w="1691640"/>
+              </a:tblGrid>
+              <a:tr h="301752">
+                <a:tc>
+                  <a:txBody>
+                    <a:bodyPr/>
+                    <a:lstStyle/>
+                    <a:p>
+                      <a:r>
+                        <a:rPr sz="950" b="1">
+                          <a:solidFill>
+                            <a:srgbClr val="FFFFFF"/>
+                          </a:solidFill>
+                          <a:latin typeface="Calibri"/>
+                        </a:rPr>
+                        <a:t>DATE</a:t>
+                      </a:r>
+                    </a:p>
+                  </a:txBody>
+                  <a:tcPr>
+                    <a:solidFill>
+                      <a:srgbClr val="075D66"/>
+                    </a:solidFill>
+                  </a:tcPr>
+                </a:tc>
+                <a:tc>
+                  <a:txBody>
+                    <a:bodyPr/>
+                    <a:lstStyle/>
+                    <a:p>
+                      <a:r>
+                        <a:rPr sz="950" b="1">
+                          <a:solidFill>
+                            <a:srgbClr val="FFFFFF"/>
+                          </a:solidFill>
+                          <a:latin typeface="Calibri"/>
+                        </a:rPr>
+                        <a:t>AIRLINE</a:t>
+                      </a:r>
+                    </a:p>
+                  </a:txBody>
+                  <a:tcPr>
+                    <a:solidFill>
+                      <a:srgbClr val="075D66"/>
+                    </a:solidFill>
+                  </a:tcPr>
+                </a:tc>
+                <a:tc>
+                  <a:txBody>
+                    <a:bodyPr/>
+                    <a:lstStyle/>
+                    <a:p>
+                      <a:r>
+                        <a:rPr sz="950" b="1">
+                          <a:solidFill>
+                            <a:srgbClr val="FFFFFF"/>
+                          </a:solidFill>
+                          <a:latin typeface="Calibri"/>
+                        </a:rPr>
+                        <a:t>ORIGIN_AIRPORT</a:t>
+                      </a:r>
+                    </a:p>
+                  </a:txBody>
+                  <a:tcPr>
+                    <a:solidFill>
+                      <a:srgbClr val="075D66"/>
+                    </a:solidFill>
+                  </a:tcPr>
+                </a:tc>
+                <a:tc>
+                  <a:txBody>
+                    <a:bodyPr/>
+                    <a:lstStyle/>
+                    <a:p>
+                      <a:r>
+                        <a:rPr sz="950" b="1">
+                          <a:solidFill>
+                            <a:srgbClr val="FFFFFF"/>
+                          </a:solidFill>
+                          <a:latin typeface="Calibri"/>
+                        </a:rPr>
+                        <a:t>DESTINATION_AIRPORT</a:t>
+                      </a:r>
+                    </a:p>
+                  </a:txBody>
+                  <a:tcPr>
+                    <a:solidFill>
+                      <a:srgbClr val="075D66"/>
+                    </a:solidFill>
+                  </a:tcPr>
+                </a:tc>
+                <a:tc>
+                  <a:txBody>
+                    <a:bodyPr/>
+                    <a:lstStyle/>
+                    <a:p>
+                      <a:r>
+                        <a:rPr sz="950" b="1">
+                          <a:solidFill>
+                            <a:srgbClr val="FFFFFF"/>
+                          </a:solidFill>
+                          <a:latin typeface="Calibri"/>
+                        </a:rPr>
+                        <a:t>DISTANCE</a:t>
+                      </a:r>
+                    </a:p>
+                  </a:txBody>
+                  <a:tcPr>
+                    <a:solidFill>
+                      <a:srgbClr val="075D66"/>
+                    </a:solidFill>
+                  </a:tcPr>
+                </a:tc>
+                <a:tc>
+                  <a:txBody>
+                    <a:bodyPr/>
+                    <a:lstStyle/>
+                    <a:p>
+                      <a:r>
+                        <a:rPr sz="950" b="1">
+                          <a:solidFill>
+                            <a:srgbClr val="FFFFFF"/>
+                          </a:solidFill>
+                          <a:latin typeface="Calibri"/>
+                        </a:rPr>
+                        <a:t>ARRIVAL_DELAY</a:t>
+                      </a:r>
+                    </a:p>
+                  </a:txBody>
+                  <a:tcPr>
+                    <a:solidFill>
+                      <a:srgbClr val="075D66"/>
+                    </a:solidFill>
+                  </a:tcPr>
+                </a:tc>
+                <a:tc>
+                  <a:txBody>
+                    <a:bodyPr/>
+                    <a:lstStyle/>
+                    <a:p>
+                      <a:r>
+                        <a:rPr sz="950" b="1">
+                          <a:solidFill>
+                            <a:srgbClr val="FFFFFF"/>
+                          </a:solidFill>
+                          <a:latin typeface="Calibri"/>
+                        </a:rPr>
+                        <a:t>CANCELLED</a:t>
+                      </a:r>
+                    </a:p>
+                  </a:txBody>
+                  <a:tcPr>
+                    <a:solidFill>
+                      <a:srgbClr val="075D66"/>
+                    </a:solidFill>
+                  </a:tcPr>
+                </a:tc>
+                <a:tc>
+                  <a:txBody>
+                    <a:bodyPr/>
+                    <a:lstStyle/>
+                    <a:p>
+                      <a:r>
+                        <a:rPr sz="950" b="1">
+                          <a:solidFill>
+                            <a:srgbClr val="FFFFFF"/>
+                          </a:solidFill>
+                          <a:latin typeface="Calibri"/>
+                        </a:rPr>
+                        <a:t>CANCELLATION_REASON</a:t>
+                      </a:r>
+                    </a:p>
+                  </a:txBody>
+                  <a:tcPr>
+                    <a:solidFill>
+                      <a:srgbClr val="075D66"/>
+                    </a:solidFill>
+                  </a:tcPr>
+                </a:tc>
+              </a:tr>
+              <a:tr h="301752">
+                <a:tc>
+                  <a:txBody>
+                    <a:bodyPr/>
+                    <a:lstStyle/>
+                    <a:p>
+                      <a:r>
+                        <a:rPr sz="1050">
+                          <a:solidFill>
+                            <a:srgbClr val="142128"/>
+                          </a:solidFill>
+                          <a:latin typeface="Calibri"/>
+                        </a:rPr>
+                        <a:t>01/04/2015</a:t>
+                      </a:r>
+                    </a:p>
+                  </a:txBody>
+                  <a:tcPr>
+                    <a:solidFill>
+                      <a:srgbClr val="FFFFFF"/>
+                    </a:solidFill>
+                  </a:tcPr>
+                </a:tc>
+                <a:tc>
+                  <a:txBody>
+                    <a:bodyPr/>
+                    <a:lstStyle/>
+                    <a:p>
+                      <a:r>
+                        <a:rPr sz="1050">
+                          <a:solidFill>
+                            <a:srgbClr val="142128"/>
+                          </a:solidFill>
+                          <a:latin typeface="Calibri"/>
+                        </a:rPr>
+                        <a:t>WN</a:t>
+                      </a:r>
+                    </a:p>
+                  </a:txBody>
+                  <a:tcPr>
+                    <a:solidFill>
+                      <a:srgbClr val="FFFFFF"/>
+                    </a:solidFill>
+                  </a:tcPr>
+                </a:tc>
+                <a:tc>
+                  <a:txBody>
+                    <a:bodyPr/>
+                    <a:lstStyle/>
+                    <a:p>
+                      <a:r>
+                        <a:rPr sz="1050">
+                          <a:solidFill>
+                            <a:srgbClr val="142128"/>
+                          </a:solidFill>
+                          <a:latin typeface="Calibri"/>
+                        </a:rPr>
+                        <a:t>ATL</a:t>
+                      </a:r>
+                    </a:p>
+                  </a:txBody>
+                  <a:tcPr>
+                    <a:solidFill>
+                      <a:srgbClr val="FFFFFF"/>
+                    </a:solidFill>
+                  </a:tcPr>
+                </a:tc>
+                <a:tc>
+                  <a:txBody>
+                    <a:bodyPr/>
+                    <a:lstStyle/>
+                    <a:p>
+                      <a:r>
+                        <a:rPr sz="1050">
+                          <a:solidFill>
+                            <a:srgbClr val="142128"/>
+                          </a:solidFill>
+                          <a:latin typeface="Calibri"/>
+                        </a:rPr>
+                        <a:t>MDW</a:t>
+                      </a:r>
+                    </a:p>
+                  </a:txBody>
+                  <a:tcPr>
+                    <a:solidFill>
+                      <a:srgbClr val="FFFFFF"/>
+                    </a:solidFill>
+                  </a:tcPr>
+                </a:tc>
+                <a:tc>
+                  <a:txBody>
+                    <a:bodyPr/>
+                    <a:lstStyle/>
+                    <a:p>
+                      <a:r>
+                        <a:rPr sz="1050">
+                          <a:solidFill>
+                            <a:srgbClr val="142128"/>
+                          </a:solidFill>
+                          <a:latin typeface="Calibri"/>
+                        </a:rPr>
+                        <a:t>591</a:t>
+                      </a:r>
+                    </a:p>
+                  </a:txBody>
+                  <a:tcPr>
+                    <a:solidFill>
+                      <a:srgbClr val="FFFFFF"/>
+                    </a:solidFill>
+                  </a:tcPr>
+                </a:tc>
+                <a:tc>
+                  <a:txBody>
+                    <a:bodyPr/>
+                    <a:lstStyle/>
+                    <a:p>
+                      <a:r>
+                        <a:rPr sz="1050">
+                          <a:solidFill>
+                            <a:srgbClr val="142128"/>
+                          </a:solidFill>
+                          <a:latin typeface="Calibri"/>
+                        </a:rPr>
+                        <a:t>-4</a:t>
+                      </a:r>
+                    </a:p>
+                  </a:txBody>
+                  <a:tcPr>
+                    <a:solidFill>
+                      <a:srgbClr val="FFFFFF"/>
+                    </a:solidFill>
+                  </a:tcPr>
+                </a:tc>
+                <a:tc>
+                  <a:txBody>
+                    <a:bodyPr/>
+                    <a:lstStyle/>
+                    <a:p>
+                      <a:r>
+                        <a:rPr sz="1050">
+                          <a:solidFill>
+                            <a:srgbClr val="142128"/>
+                          </a:solidFill>
+                          <a:latin typeface="Calibri"/>
+                        </a:rPr>
+                        <a:t>0</a:t>
+                      </a:r>
+                    </a:p>
+                  </a:txBody>
+                  <a:tcPr>
+                    <a:solidFill>
+                      <a:srgbClr val="FFFFFF"/>
+                    </a:solidFill>
+                  </a:tcPr>
+                </a:tc>
+                <a:tc>
+                  <a:txBody>
+                    <a:bodyPr/>
+                    <a:lstStyle/>
+                    <a:p/>
+                  </a:txBody>
+                  <a:tcPr>
+                    <a:solidFill>
+                      <a:srgbClr val="FFFFFF"/>
+                    </a:solidFill>
+                  </a:tcPr>
+                </a:tc>
+              </a:tr>
+              <a:tr h="301752">
+                <a:tc>
+                  <a:txBody>
+                    <a:bodyPr/>
+                    <a:lstStyle/>
+                    <a:p>
+                      <a:r>
+                        <a:rPr sz="1050">
+                          <a:solidFill>
+                            <a:srgbClr val="142128"/>
+                          </a:solidFill>
+                          <a:latin typeface="Calibri"/>
+                        </a:rPr>
+                        <a:t>01/06/2015</a:t>
+                      </a:r>
+                    </a:p>
+                  </a:txBody>
+                  <a:tcPr>
+                    <a:solidFill>
+                      <a:srgbClr val="F4F7F8"/>
+                    </a:solidFill>
+                  </a:tcPr>
+                </a:tc>
+                <a:tc>
+                  <a:txBody>
+                    <a:bodyPr/>
+                    <a:lstStyle/>
+                    <a:p>
+                      <a:r>
+                        <a:rPr sz="1050">
+                          <a:solidFill>
+                            <a:srgbClr val="142128"/>
+                          </a:solidFill>
+                          <a:latin typeface="Calibri"/>
+                        </a:rPr>
+                        <a:t>NK</a:t>
+                      </a:r>
+                    </a:p>
+                  </a:txBody>
+                  <a:tcPr>
+                    <a:solidFill>
+                      <a:srgbClr val="F4F7F8"/>
+                    </a:solidFill>
+                  </a:tcPr>
+                </a:tc>
+                <a:tc>
+                  <a:txBody>
+                    <a:bodyPr/>
+                    <a:lstStyle/>
+                    <a:p>
+                      <a:r>
+                        <a:rPr sz="1050">
+                          <a:solidFill>
+                            <a:srgbClr val="142128"/>
+                          </a:solidFill>
+                          <a:latin typeface="Calibri"/>
+                        </a:rPr>
+                        <a:t>ORD</a:t>
+                      </a:r>
+                    </a:p>
+                  </a:txBody>
+                  <a:tcPr>
+                    <a:solidFill>
+                      <a:srgbClr val="F4F7F8"/>
+                    </a:solidFill>
+                  </a:tcPr>
+                </a:tc>
+                <a:tc>
+                  <a:txBody>
+                    <a:bodyPr/>
+                    <a:lstStyle/>
+                    <a:p>
+                      <a:r>
+                        <a:rPr sz="1050">
+                          <a:solidFill>
+                            <a:srgbClr val="142128"/>
+                          </a:solidFill>
+                          <a:latin typeface="Calibri"/>
+                        </a:rPr>
+                        <a:t>LGA</a:t>
+                      </a:r>
+                    </a:p>
+                  </a:txBody>
+                  <a:tcPr>
+                    <a:solidFill>
+                      <a:srgbClr val="F4F7F8"/>
+                    </a:solidFill>
+                  </a:tcPr>
+                </a:tc>
+                <a:tc>
+                  <a:txBody>
+                    <a:bodyPr/>
+                    <a:lstStyle/>
+                    <a:p>
+                      <a:r>
+                        <a:rPr sz="1050">
+                          <a:solidFill>
+                            <a:srgbClr val="142128"/>
+                          </a:solidFill>
+                          <a:latin typeface="Calibri"/>
+                        </a:rPr>
+                        <a:t>733</a:t>
+                      </a:r>
+                    </a:p>
+                  </a:txBody>
+                  <a:tcPr>
+                    <a:solidFill>
+                      <a:srgbClr val="F4F7F8"/>
+                    </a:solidFill>
+                  </a:tcPr>
+                </a:tc>
+                <a:tc>
+                  <a:txBody>
+                    <a:bodyPr/>
+                    <a:lstStyle/>
+                    <a:p>
+                      <a:r>
+                        <a:rPr sz="1050">
+                          <a:solidFill>
+                            <a:srgbClr val="142128"/>
+                          </a:solidFill>
+                          <a:latin typeface="Calibri"/>
+                        </a:rPr>
+                        <a:t>+85</a:t>
+                      </a:r>
+                    </a:p>
+                  </a:txBody>
+                  <a:tcPr>
+                    <a:solidFill>
+                      <a:srgbClr val="F4F7F8"/>
+                    </a:solidFill>
+                  </a:tcPr>
+                </a:tc>
+                <a:tc>
+                  <a:txBody>
+                    <a:bodyPr/>
+                    <a:lstStyle/>
+                    <a:p>
+                      <a:r>
+                        <a:rPr sz="1050">
+                          <a:solidFill>
+                            <a:srgbClr val="142128"/>
+                          </a:solidFill>
+                          <a:latin typeface="Calibri"/>
+                        </a:rPr>
+                        <a:t>0</a:t>
+                      </a:r>
+                    </a:p>
+                  </a:txBody>
+                  <a:tcPr>
+                    <a:solidFill>
+                      <a:srgbClr val="F4F7F8"/>
+                    </a:solidFill>
+                  </a:tcPr>
+                </a:tc>
+                <a:tc>
+                  <a:txBody>
+                    <a:bodyPr/>
+                    <a:lstStyle/>
+                    <a:p/>
+                  </a:txBody>
+                  <a:tcPr>
+                    <a:solidFill>
+                      <a:srgbClr val="F4F7F8"/>
+                    </a:solidFill>
+                  </a:tcPr>
+                </a:tc>
+              </a:tr>
+              <a:tr h="301752">
+                <a:tc>
+                  <a:txBody>
+                    <a:bodyPr/>
+                    <a:lstStyle/>
+                    <a:p>
+                      <a:r>
+                        <a:rPr sz="1050">
+                          <a:solidFill>
+                            <a:srgbClr val="142128"/>
+                          </a:solidFill>
+                          <a:latin typeface="Calibri"/>
+                        </a:rPr>
+                        <a:t>01/02/2015</a:t>
+                      </a:r>
+                    </a:p>
+                  </a:txBody>
+                  <a:tcPr>
+                    <a:solidFill>
+                      <a:srgbClr val="FFFFFF"/>
+                    </a:solidFill>
+                  </a:tcPr>
+                </a:tc>
+                <a:tc>
+                  <a:txBody>
+                    <a:bodyPr/>
+                    <a:lstStyle/>
+                    <a:p>
+                      <a:r>
+                        <a:rPr sz="1050">
+                          <a:solidFill>
+                            <a:srgbClr val="142128"/>
+                          </a:solidFill>
+                          <a:latin typeface="Calibri"/>
+                        </a:rPr>
+                        <a:t>B6</a:t>
+                      </a:r>
+                    </a:p>
+                  </a:txBody>
+                  <a:tcPr>
+                    <a:solidFill>
+                      <a:srgbClr val="FFFFFF"/>
+                    </a:solidFill>
+                  </a:tcPr>
+                </a:tc>
+                <a:tc>
+                  <a:txBody>
+                    <a:bodyPr/>
+                    <a:lstStyle/>
+                    <a:p>
+                      <a:r>
+                        <a:rPr sz="1050">
+                          <a:solidFill>
+                            <a:srgbClr val="142128"/>
+                          </a:solidFill>
+                          <a:latin typeface="Calibri"/>
+                        </a:rPr>
+                        <a:t>BOS</a:t>
+                      </a:r>
+                    </a:p>
+                  </a:txBody>
+                  <a:tcPr>
+                    <a:solidFill>
+                      <a:srgbClr val="FFFFFF"/>
+                    </a:solidFill>
+                  </a:tcPr>
+                </a:tc>
+                <a:tc>
+                  <a:txBody>
+                    <a:bodyPr/>
+                    <a:lstStyle/>
+                    <a:p>
+                      <a:r>
+                        <a:rPr sz="1050">
+                          <a:solidFill>
+                            <a:srgbClr val="142128"/>
+                          </a:solidFill>
+                          <a:latin typeface="Calibri"/>
+                        </a:rPr>
+                        <a:t>ORD</a:t>
+                      </a:r>
+                    </a:p>
+                  </a:txBody>
+                  <a:tcPr>
+                    <a:solidFill>
+                      <a:srgbClr val="FFFFFF"/>
+                    </a:solidFill>
+                  </a:tcPr>
+                </a:tc>
+                <a:tc>
+                  <a:txBody>
+                    <a:bodyPr/>
+                    <a:lstStyle/>
+                    <a:p>
+                      <a:r>
+                        <a:rPr sz="1050">
+                          <a:solidFill>
+                            <a:srgbClr val="142128"/>
+                          </a:solidFill>
+                          <a:latin typeface="Calibri"/>
+                        </a:rPr>
+                        <a:t>867</a:t>
+                      </a:r>
+                    </a:p>
+                  </a:txBody>
+                  <a:tcPr>
+                    <a:solidFill>
+                      <a:srgbClr val="FFFFFF"/>
+                    </a:solidFill>
+                  </a:tcPr>
+                </a:tc>
+                <a:tc>
+                  <a:txBody>
+                    <a:bodyPr/>
+                    <a:lstStyle/>
+                    <a:p/>
+                  </a:txBody>
+                  <a:tcPr>
+                    <a:solidFill>
+                      <a:srgbClr val="FFFFFF"/>
+                    </a:solidFill>
+                  </a:tcPr>
+                </a:tc>
+                <a:tc>
+                  <a:txBody>
+                    <a:bodyPr/>
+                    <a:lstStyle/>
+                    <a:p>
+                      <a:r>
+                        <a:rPr sz="1050">
+                          <a:solidFill>
+                            <a:srgbClr val="142128"/>
+                          </a:solidFill>
+                          <a:latin typeface="Calibri"/>
+                        </a:rPr>
+                        <a:t>1</a:t>
+                      </a:r>
+                    </a:p>
+                  </a:txBody>
+                  <a:tcPr>
+                    <a:solidFill>
+                      <a:srgbClr val="FFFFFF"/>
+                    </a:solidFill>
+                  </a:tcPr>
+                </a:tc>
+                <a:tc>
+                  <a:txBody>
+                    <a:bodyPr/>
+                    <a:lstStyle/>
+                    <a:p>
+                      <a:r>
+                        <a:rPr sz="1050">
+                          <a:solidFill>
+                            <a:srgbClr val="142128"/>
+                          </a:solidFill>
+                          <a:latin typeface="Calibri"/>
+                        </a:rPr>
+                        <a:t>B</a:t>
+                      </a:r>
+                    </a:p>
+                  </a:txBody>
+                  <a:tcPr>
+                    <a:solidFill>
+                      <a:srgbClr val="FFFFFF"/>
+                    </a:solidFill>
+                  </a:tcPr>
+                </a:tc>
+              </a:tr>
+              <a:tr h="301752">
+                <a:tc>
+                  <a:txBody>
+                    <a:bodyPr/>
+                    <a:lstStyle/>
+                    <a:p>
+                      <a:r>
+                        <a:rPr sz="1050">
+                          <a:solidFill>
+                            <a:srgbClr val="142128"/>
+                          </a:solidFill>
+                          <a:latin typeface="Calibri"/>
+                        </a:rPr>
+                        <a:t>01/01/2015</a:t>
+                      </a:r>
+                    </a:p>
+                  </a:txBody>
+                  <a:tcPr>
+                    <a:solidFill>
+                      <a:srgbClr val="F4F7F8"/>
+                    </a:solidFill>
+                  </a:tcPr>
+                </a:tc>
+                <a:tc>
+                  <a:txBody>
+                    <a:bodyPr/>
+                    <a:lstStyle/>
+                    <a:p>
+                      <a:r>
+                        <a:rPr sz="1050">
+                          <a:solidFill>
+                            <a:srgbClr val="142128"/>
+                          </a:solidFill>
+                          <a:latin typeface="Calibri"/>
+                        </a:rPr>
+                        <a:t>DL</a:t>
+                      </a:r>
+                    </a:p>
+                  </a:txBody>
+                  <a:tcPr>
+                    <a:solidFill>
+                      <a:srgbClr val="F4F7F8"/>
+                    </a:solidFill>
+                  </a:tcPr>
+                </a:tc>
+                <a:tc>
+                  <a:txBody>
+                    <a:bodyPr/>
+                    <a:lstStyle/>
+                    <a:p>
+                      <a:r>
+                        <a:rPr sz="1050">
+                          <a:solidFill>
+                            <a:srgbClr val="142128"/>
+                          </a:solidFill>
+                          <a:latin typeface="Calibri"/>
+                        </a:rPr>
+                        <a:t>JFK</a:t>
+                      </a:r>
+                    </a:p>
+                  </a:txBody>
+                  <a:tcPr>
+                    <a:solidFill>
+                      <a:srgbClr val="F4F7F8"/>
+                    </a:solidFill>
+                  </a:tcPr>
+                </a:tc>
+                <a:tc>
+                  <a:txBody>
+                    <a:bodyPr/>
+                    <a:lstStyle/>
+                    <a:p>
+                      <a:r>
+                        <a:rPr sz="1050">
+                          <a:solidFill>
+                            <a:srgbClr val="142128"/>
+                          </a:solidFill>
+                          <a:latin typeface="Calibri"/>
+                        </a:rPr>
+                        <a:t>LAX</a:t>
+                      </a:r>
+                    </a:p>
+                  </a:txBody>
+                  <a:tcPr>
+                    <a:solidFill>
+                      <a:srgbClr val="F4F7F8"/>
+                    </a:solidFill>
+                  </a:tcPr>
+                </a:tc>
+                <a:tc>
+                  <a:txBody>
+                    <a:bodyPr/>
+                    <a:lstStyle/>
+                    <a:p>
+                      <a:r>
+                        <a:rPr sz="1050">
+                          <a:solidFill>
+                            <a:srgbClr val="142128"/>
+                          </a:solidFill>
+                          <a:latin typeface="Calibri"/>
+                        </a:rPr>
+                        <a:t>2475</a:t>
+                      </a:r>
+                    </a:p>
+                  </a:txBody>
+                  <a:tcPr>
+                    <a:solidFill>
+                      <a:srgbClr val="F4F7F8"/>
+                    </a:solidFill>
+                  </a:tcPr>
+                </a:tc>
+                <a:tc>
+                  <a:txBody>
+                    <a:bodyPr/>
+                    <a:lstStyle/>
+                    <a:p>
+                      <a:r>
+                        <a:rPr sz="1050">
+                          <a:solidFill>
+                            <a:srgbClr val="142128"/>
+                          </a:solidFill>
+                          <a:latin typeface="Calibri"/>
+                        </a:rPr>
+                        <a:t>-10</a:t>
+                      </a:r>
+                    </a:p>
+                  </a:txBody>
+                  <a:tcPr>
+                    <a:solidFill>
+                      <a:srgbClr val="F4F7F8"/>
+                    </a:solidFill>
+                  </a:tcPr>
+                </a:tc>
+                <a:tc>
+                  <a:txBody>
+                    <a:bodyPr/>
+                    <a:lstStyle/>
+                    <a:p>
+                      <a:r>
+                        <a:rPr sz="1050">
+                          <a:solidFill>
+                            <a:srgbClr val="142128"/>
+                          </a:solidFill>
+                          <a:latin typeface="Calibri"/>
+                        </a:rPr>
+                        <a:t>0</a:t>
+                      </a:r>
+                    </a:p>
+                  </a:txBody>
+                  <a:tcPr>
+                    <a:solidFill>
+                      <a:srgbClr val="F4F7F8"/>
+                    </a:solidFill>
+                  </a:tcPr>
+                </a:tc>
+                <a:tc>
+                  <a:txBody>
+                    <a:bodyPr/>
+                    <a:lstStyle/>
+                    <a:p/>
+                  </a:txBody>
+                  <a:tcPr>
+                    <a:solidFill>
+                      <a:srgbClr val="F4F7F8"/>
+                    </a:solidFill>
+                  </a:tcPr>
+                </a:tc>
+              </a:tr>
+            </a:tbl>
+          </a:graphicData>
+        </a:graphic>
+      </p:graphicFrame>
+      <p:sp>
+        <p:nvSpPr>
+          <p:cNvPr id="32" name="TextBox 31"/>
+          <p:cNvSpPr txBox="1"/>
+          <p:nvPr/>
+        </p:nvSpPr>
+        <p:spPr>
+          <a:xfrm>
+            <a:off x="502920" y="4434840"/>
+            <a:ext cx="11155680" cy="274320"/>
+          </a:xfrm>
+          <a:prstGeom prst="rect">
+            <a:avLst/>
+          </a:prstGeom>
+          <a:noFill/>
+        </p:spPr>
+        <p:txBody>
+          <a:bodyPr wrap="square" anchor="t">
+            <a:spAutoFit/>
+          </a:bodyPr>
+          <a:lstStyle/>
+          <a:p>
+            <a:pPr algn="l">
+              <a:spcAft>
+                <a:spcPts val="400"/>
+              </a:spcAft>
+            </a:pPr>
+            <a:r>
+              <a:rPr sz="1200" b="1">
+                <a:solidFill>
+                  <a:srgbClr val="687985"/>
+                </a:solidFill>
+                <a:latin typeface="Calibri"/>
+              </a:rPr>
+              <a:t>Les colonnes clés :</a:t>
+            </a:r>
+          </a:p>
+        </p:txBody>
+      </p:sp>
+      <p:sp>
+        <p:nvSpPr>
+          <p:cNvPr id="33" name="TextBox 32"/>
+          <p:cNvSpPr txBox="1"/>
+          <p:nvPr/>
+        </p:nvSpPr>
+        <p:spPr>
+          <a:xfrm>
+            <a:off x="502920" y="4736592"/>
+            <a:ext cx="5486400" cy="1645920"/>
+          </a:xfrm>
+          <a:prstGeom prst="rect">
+            <a:avLst/>
+          </a:prstGeom>
+          <a:noFill/>
+        </p:spPr>
+        <p:txBody>
+          <a:bodyPr wrap="square" anchor="t">
+            <a:spAutoFit/>
+          </a:bodyPr>
+          <a:lstStyle/>
+          <a:p>
+            <a:pPr algn="l">
+              <a:lnSpc>
+                <a:spcPct val="105000"/>
+              </a:lnSpc>
+              <a:spcAft>
+                <a:spcPts val="700"/>
+              </a:spcAft>
+            </a:pPr>
+            <a:r>
+              <a:rPr sz="1250" b="1">
+                <a:solidFill>
+                  <a:srgbClr val="0C8792"/>
+                </a:solidFill>
+                <a:latin typeface="Calibri"/>
+              </a:rPr>
+              <a:t>▪  </a:t>
+            </a:r>
+            <a:r>
+              <a:rPr sz="1250" b="1">
+                <a:solidFill>
+                  <a:srgbClr val="075D66"/>
+                </a:solidFill>
+                <a:latin typeface="Calibri"/>
+              </a:rPr>
+              <a:t>AIRLINE</a:t>
+            </a:r>
+            <a:r>
+              <a:rPr sz="1250" b="0">
+                <a:solidFill>
+                  <a:srgbClr val="142128"/>
+                </a:solidFill>
+                <a:latin typeface="Calibri"/>
+              </a:rPr>
+              <a:t> : code de la compagnie aérienne (14 compagnies)</a:t>
+            </a:r>
+          </a:p>
+          <a:p>
+            <a:pPr algn="l">
+              <a:lnSpc>
+                <a:spcPct val="105000"/>
+              </a:lnSpc>
+              <a:spcAft>
+                <a:spcPts val="700"/>
+              </a:spcAft>
+            </a:pPr>
+            <a:r>
+              <a:rPr sz="1250" b="1">
+                <a:solidFill>
+                  <a:srgbClr val="0C8792"/>
+                </a:solidFill>
+                <a:latin typeface="Calibri"/>
+              </a:rPr>
+              <a:t>▪  </a:t>
+            </a:r>
+            <a:r>
+              <a:rPr sz="1250" b="1">
+                <a:solidFill>
+                  <a:srgbClr val="075D66"/>
+                </a:solidFill>
+                <a:latin typeface="Calibri"/>
+              </a:rPr>
+              <a:t>ORIGIN / DESTINATION_AIRPORT</a:t>
+            </a:r>
+            <a:r>
+              <a:rPr sz="1250" b="0">
+                <a:solidFill>
+                  <a:srgbClr val="142128"/>
+                </a:solidFill>
+                <a:latin typeface="Calibri"/>
+              </a:rPr>
+              <a:t> : aéroports de départ et d'arrivée</a:t>
+            </a:r>
+          </a:p>
+          <a:p>
+            <a:pPr algn="l">
+              <a:lnSpc>
+                <a:spcPct val="105000"/>
+              </a:lnSpc>
+              <a:spcAft>
+                <a:spcPts val="700"/>
+              </a:spcAft>
+            </a:pPr>
+            <a:r>
+              <a:rPr sz="1250" b="1">
+                <a:solidFill>
+                  <a:srgbClr val="0C8792"/>
+                </a:solidFill>
+                <a:latin typeface="Calibri"/>
+              </a:rPr>
+              <a:t>▪  </a:t>
+            </a:r>
+            <a:r>
+              <a:rPr sz="1250" b="1">
+                <a:solidFill>
+                  <a:srgbClr val="075D66"/>
+                </a:solidFill>
+                <a:latin typeface="Calibri"/>
+              </a:rPr>
+              <a:t>DISTANCE</a:t>
+            </a:r>
+            <a:r>
+              <a:rPr sz="1250" b="0">
+                <a:solidFill>
+                  <a:srgbClr val="142128"/>
+                </a:solidFill>
+                <a:latin typeface="Calibri"/>
+              </a:rPr>
+              <a:t> : distance du vol en miles (1500 mi et plus = vol long)</a:t>
+            </a:r>
+          </a:p>
+        </p:txBody>
+      </p:sp>
+      <p:sp>
+        <p:nvSpPr>
+          <p:cNvPr id="34" name="TextBox 33"/>
+          <p:cNvSpPr txBox="1"/>
+          <p:nvPr/>
+        </p:nvSpPr>
+        <p:spPr>
+          <a:xfrm>
+            <a:off x="6172200" y="4736592"/>
+            <a:ext cx="5486400" cy="1645920"/>
+          </a:xfrm>
+          <a:prstGeom prst="rect">
+            <a:avLst/>
+          </a:prstGeom>
+          <a:noFill/>
+        </p:spPr>
+        <p:txBody>
+          <a:bodyPr wrap="square" anchor="t">
+            <a:spAutoFit/>
+          </a:bodyPr>
+          <a:lstStyle/>
+          <a:p>
+            <a:pPr algn="l">
+              <a:lnSpc>
+                <a:spcPct val="105000"/>
+              </a:lnSpc>
+              <a:spcAft>
+                <a:spcPts val="700"/>
+              </a:spcAft>
+            </a:pPr>
+            <a:r>
+              <a:rPr sz="1250" b="1">
+                <a:solidFill>
+                  <a:srgbClr val="0C8792"/>
+                </a:solidFill>
+                <a:latin typeface="Calibri"/>
+              </a:rPr>
+              <a:t>▪  </a:t>
+            </a:r>
+            <a:r>
+              <a:rPr sz="1250" b="1">
+                <a:solidFill>
+                  <a:srgbClr val="075D66"/>
+                </a:solidFill>
+                <a:latin typeface="Calibri"/>
+              </a:rPr>
+              <a:t>ARRIVAL_DELAY</a:t>
+            </a:r>
+            <a:r>
+              <a:rPr sz="1250" b="0">
+                <a:solidFill>
+                  <a:srgbClr val="142128"/>
+                </a:solidFill>
+                <a:latin typeface="Calibri"/>
+              </a:rPr>
+              <a:t> : retard à l'arrivée en minutes (négatif = en avance)</a:t>
+            </a:r>
+          </a:p>
+          <a:p>
+            <a:pPr algn="l">
+              <a:lnSpc>
+                <a:spcPct val="105000"/>
+              </a:lnSpc>
+              <a:spcAft>
+                <a:spcPts val="700"/>
+              </a:spcAft>
+            </a:pPr>
+            <a:r>
+              <a:rPr sz="1250" b="1">
+                <a:solidFill>
+                  <a:srgbClr val="0C8792"/>
+                </a:solidFill>
+                <a:latin typeface="Calibri"/>
+              </a:rPr>
+              <a:t>▪  </a:t>
+            </a:r>
+            <a:r>
+              <a:rPr sz="1250" b="1">
+                <a:solidFill>
+                  <a:srgbClr val="075D66"/>
+                </a:solidFill>
+                <a:latin typeface="Calibri"/>
+              </a:rPr>
+              <a:t>CANCELLED + CANCELLATION_REASON</a:t>
+            </a:r>
+            <a:r>
+              <a:rPr sz="1250" b="0">
+                <a:solidFill>
+                  <a:srgbClr val="142128"/>
+                </a:solidFill>
+                <a:latin typeface="Calibri"/>
+              </a:rPr>
+              <a:t> : annulation et son motif (A compagnie, B météo, C contrôle aérien, D sécurité)</a:t>
+            </a:r>
+          </a:p>
+          <a:p>
+            <a:pPr algn="l">
+              <a:lnSpc>
+                <a:spcPct val="105000"/>
+              </a:lnSpc>
+              <a:spcAft>
+                <a:spcPts val="700"/>
+              </a:spcAft>
+            </a:pPr>
+            <a:r>
+              <a:rPr sz="1250" b="1">
+                <a:solidFill>
+                  <a:srgbClr val="0C8792"/>
+                </a:solidFill>
+                <a:latin typeface="Calibri"/>
+              </a:rPr>
+              <a:t>▪  </a:t>
+            </a:r>
+            <a:r>
+              <a:rPr sz="1250" b="1">
+                <a:solidFill>
+                  <a:srgbClr val="075D66"/>
+                </a:solidFill>
+                <a:latin typeface="Calibri"/>
+              </a:rPr>
+              <a:t>WEATHER_DELAY, LATE_AIRCRAFT_DELAY…</a:t>
+            </a:r>
+            <a:r>
+              <a:rPr sz="1250" b="0">
+                <a:solidFill>
+                  <a:srgbClr val="142128"/>
+                </a:solidFill>
+                <a:latin typeface="Calibri"/>
+              </a:rPr>
+              <a:t> : décomposition des minutes de retard par cause</a:t>
+            </a:r>
+          </a:p>
+        </p:txBody>
+      </p:sp>
+      <p:sp>
+        <p:nvSpPr>
+          <p:cNvPr id="37" name="TextBox 36"/>
+          <p:cNvSpPr txBox="1"/>
+          <p:nvPr/>
+        </p:nvSpPr>
+        <p:spPr>
+          <a:xfrm>
+            <a:off x="502920" y="6053328"/>
+            <a:ext cx="11155680" cy="347472"/>
+          </a:xfrm>
+          <a:prstGeom prst="rect">
+            <a:avLst/>
+          </a:prstGeom>
+          <a:noFill/>
+        </p:spPr>
+        <p:txBody>
+          <a:bodyPr wrap="square">
+            <a:spAutoFit/>
+          </a:bodyPr>
+          <a:lstStyle/>
+          <a:p>
+            <a:r>
+              <a:rPr sz="1150" b="1">
+                <a:solidFill>
+                  <a:srgbClr val="075D66"/>
+                </a:solidFill>
+                <a:latin typeface="Calibri"/>
+              </a:rPr>
+              <a:t>Fichiers annexes, joints par le code IATA — </a:t>
+            </a:r>
+            <a:r>
+              <a:rPr sz="1150" b="1">
+                <a:solidFill>
+                  <a:srgbClr val="687985"/>
+                </a:solidFill>
+                <a:latin typeface="Calibri"/>
+              </a:rPr>
+              <a:t>airlines.csv</a:t>
+            </a:r>
+            <a:r>
+              <a:rPr sz="1150" b="0">
+                <a:solidFill>
+                  <a:srgbClr val="687985"/>
+                </a:solidFill>
+                <a:latin typeface="Calibri"/>
+              </a:rPr>
+              <a:t> : code → nom de la compagnie (14 lignes)   ·   </a:t>
+            </a:r>
+            <a:r>
+              <a:rPr sz="1150" b="1">
+                <a:solidFill>
+                  <a:srgbClr val="687985"/>
+                </a:solidFill>
+                <a:latin typeface="Calibri"/>
+              </a:rPr>
+              <a:t>airports.csv</a:t>
+            </a:r>
+            <a:r>
+              <a:rPr sz="1150" b="0">
+                <a:solidFill>
+                  <a:srgbClr val="687985"/>
+                </a:solidFill>
+                <a:latin typeface="Calibri"/>
+              </a:rPr>
+              <a:t> : code, ville, État, latitude/longitude — le fond de la carte (322 lignes)</a:t>
             </a:r>
           </a:p>
         </p:txBody>
@@ -4754,7 +5194,7 @@
       </p:grpSpPr>
       <p:sp>
         <p:nvSpPr>
-          <p:cNvPr id="2" name="Rectangle 1"/>
+          <p:cNvPr id="28" name="Rectangle 27"/>
           <p:cNvSpPr/>
           <p:nvPr/>
         </p:nvSpPr>
@@ -4793,13 +5233,12 @@
           <a:lstStyle/>
           <a:p>
             <a:pPr algn="ctr"/>
-            <a:endParaRPr/>
-          </a:p>
-        </p:txBody>
-      </p:sp>
-      <p:sp>
-        <p:nvSpPr>
-          <p:cNvPr id="3" name="Rectangle 2"/>
+          </a:p>
+        </p:txBody>
+      </p:sp>
+      <p:sp>
+        <p:nvSpPr>
+          <p:cNvPr id="29" name="Rectangle 28"/>
           <p:cNvSpPr/>
           <p:nvPr/>
         </p:nvSpPr>
@@ -4838,7 +5277,6 @@
           <a:lstStyle/>
           <a:p>
             <a:pPr algn="ctr"/>
-            <a:endParaRPr/>
           </a:p>
         </p:txBody>
       </p:sp>
@@ -4876,7 +5314,7 @@
                 </a:solidFill>
                 <a:latin typeface="Calibri"/>
               </a:rPr>
-              <a:t>PRÉPARATION DES DONNÉES</a:t>
+              <a:t>TRAITEMENTS DES DONNÉES</a:t>
             </a:r>
           </a:p>
         </p:txBody>
@@ -4915,215 +5353,7 @@
                 </a:solidFill>
                 <a:latin typeface="Calibri"/>
               </a:rPr>
-              <a:t>Un nettoyage guidé par un audit qualité</a:t>
-            </a:r>
-          </a:p>
-        </p:txBody>
-      </p:sp>
-      <p:sp>
-        <p:nvSpPr>
-          <p:cNvPr id="6" name="TextBox 5"/>
-          <p:cNvSpPr txBox="1"/>
-          <p:nvPr/>
-        </p:nvSpPr>
-        <p:spPr>
-          <a:xfrm>
-            <a:off x="502920" y="1691640"/>
-            <a:ext cx="11155680" cy="4206240"/>
-          </a:xfrm>
-          <a:prstGeom prst="rect">
-            <a:avLst/>
-          </a:prstGeom>
-          <a:noFill/>
-        </p:spPr>
-        <p:txBody>
-          <a:bodyPr wrap="square" anchor="t">
-            <a:spAutoFit/>
-          </a:bodyPr>
-          <a:lstStyle/>
-          <a:p>
-            <a:pPr algn="l">
-              <a:lnSpc>
-                <a:spcPct val="112000"/>
-              </a:lnSpc>
-              <a:spcAft>
-                <a:spcPts val="1200"/>
-              </a:spcAft>
-            </a:pPr>
-            <a:r>
-              <a:rPr sz="1700" b="1" i="0">
-                <a:solidFill>
-                  <a:srgbClr val="0C8792"/>
-                </a:solidFill>
-                <a:latin typeface="Calibri"/>
-              </a:rPr>
-              <a:t>▪  </a:t>
-            </a:r>
-            <a:r>
-              <a:rPr sz="1700" b="1" i="0">
-                <a:solidFill>
-                  <a:srgbClr val="142128"/>
-                </a:solidFill>
-                <a:latin typeface="Calibri"/>
-              </a:rPr>
-              <a:t>Chargement maîtrisé</a:t>
-            </a:r>
-            <a:r>
-              <a:rPr sz="1700" b="0" i="0">
-                <a:solidFill>
-                  <a:srgbClr val="142128"/>
-                </a:solidFill>
-                <a:latin typeface="Calibri"/>
-              </a:rPr>
-              <a:t> — seules les colonnes utiles du fichier de 592 Mo sont lues, avec des types compacts pour tenir en mémoire</a:t>
-            </a:r>
-          </a:p>
-          <a:p>
-            <a:pPr algn="l">
-              <a:lnSpc>
-                <a:spcPct val="112000"/>
-              </a:lnSpc>
-              <a:spcAft>
-                <a:spcPts val="1200"/>
-              </a:spcAft>
-            </a:pPr>
-            <a:r>
-              <a:rPr sz="1700" b="1" i="0">
-                <a:solidFill>
-                  <a:srgbClr val="0C8792"/>
-                </a:solidFill>
-                <a:latin typeface="Calibri"/>
-              </a:rPr>
-              <a:t>▪  </a:t>
-            </a:r>
-            <a:r>
-              <a:rPr sz="1700" b="1" i="0">
-                <a:solidFill>
-                  <a:srgbClr val="142128"/>
-                </a:solidFill>
-                <a:latin typeface="Calibri"/>
-              </a:rPr>
-              <a:t>Valeurs manquantes expliquées</a:t>
-            </a:r>
-            <a:r>
-              <a:rPr sz="1700" b="0" i="0">
-                <a:solidFill>
-                  <a:srgbClr val="142128"/>
-                </a:solidFill>
-                <a:latin typeface="Calibri"/>
-              </a:rPr>
-              <a:t> — 105 071 retards absents correspondent exactement aux vols annulés ou déroutés : ils sont retirés du calcul des retards au lieu d'être comptés « à l'heure »</a:t>
-            </a:r>
-          </a:p>
-          <a:p>
-            <a:pPr algn="l">
-              <a:lnSpc>
-                <a:spcPct val="112000"/>
-              </a:lnSpc>
-              <a:spcAft>
-                <a:spcPts val="1200"/>
-              </a:spcAft>
-            </a:pPr>
-            <a:r>
-              <a:rPr sz="1700" b="1" i="0">
-                <a:solidFill>
-                  <a:srgbClr val="0C8792"/>
-                </a:solidFill>
-                <a:latin typeface="Calibri"/>
-              </a:rPr>
-              <a:t>▪  </a:t>
-            </a:r>
-            <a:r>
-              <a:rPr sz="1700" b="1" i="0">
-                <a:solidFill>
-                  <a:srgbClr val="142128"/>
-                </a:solidFill>
-                <a:latin typeface="Calibri"/>
-              </a:rPr>
-              <a:t>Anomalie détectée sur octobre</a:t>
-            </a:r>
-            <a:r>
-              <a:rPr sz="1700" b="0" i="0">
-                <a:solidFill>
-                  <a:srgbClr val="142128"/>
-                </a:solidFill>
-                <a:latin typeface="Calibri"/>
-              </a:rPr>
-              <a:t> — les aéroports y sont codés différemment du reste de l'année ; le mois est écarté de la seule analyse des liaisons (2,7 % des annulations)</a:t>
-            </a:r>
-          </a:p>
-          <a:p>
-            <a:pPr algn="l">
-              <a:lnSpc>
-                <a:spcPct val="112000"/>
-              </a:lnSpc>
-              <a:spcAft>
-                <a:spcPts val="1200"/>
-              </a:spcAft>
-            </a:pPr>
-            <a:r>
-              <a:rPr sz="1700" b="1" i="0">
-                <a:solidFill>
-                  <a:srgbClr val="0C8792"/>
-                </a:solidFill>
-                <a:latin typeface="Calibri"/>
-              </a:rPr>
-              <a:t>▪  </a:t>
-            </a:r>
-            <a:r>
-              <a:rPr sz="1700" b="1" i="0">
-                <a:solidFill>
-                  <a:srgbClr val="142128"/>
-                </a:solidFill>
-                <a:latin typeface="Calibri"/>
-              </a:rPr>
-              <a:t>Définitions officielles</a:t>
-            </a:r>
-            <a:r>
-              <a:rPr sz="1700" b="0" i="0">
-                <a:solidFill>
-                  <a:srgbClr val="142128"/>
-                </a:solidFill>
-                <a:latin typeface="Calibri"/>
-              </a:rPr>
-              <a:t> — un vol est « en retard » à partir de 15 minutes à l'arrivée (norme du US DOT) ; les périodes de vacances 2015 sont bornées explicitement</a:t>
-            </a:r>
-          </a:p>
-          <a:p>
-            <a:pPr algn="l">
-              <a:lnSpc>
-                <a:spcPct val="112000"/>
-              </a:lnSpc>
-              <a:spcAft>
-                <a:spcPts val="1200"/>
-              </a:spcAft>
-            </a:pPr>
-            <a:r>
-              <a:rPr sz="1700" b="1" i="0">
-                <a:solidFill>
-                  <a:srgbClr val="0C8792"/>
-                </a:solidFill>
-                <a:latin typeface="Calibri"/>
-              </a:rPr>
-              <a:t>▪  </a:t>
-            </a:r>
-            <a:r>
-              <a:rPr sz="1700" b="1" i="0">
-                <a:solidFill>
-                  <a:srgbClr val="142128"/>
-                </a:solidFill>
-                <a:latin typeface="Calibri"/>
-              </a:rPr>
-              <a:t>Résultats reproductibles</a:t>
-            </a:r>
-            <a:r>
-              <a:rPr sz="1700" b="0" i="0">
-                <a:solidFill>
-                  <a:srgbClr val="142128"/>
-                </a:solidFill>
-                <a:latin typeface="Calibri"/>
-              </a:rPr>
-              <a:t> — aucun chiffre saisi à la main : tableaux, graphiques et dashboard sont générés par le notebook, une ré-exécution met tout à jour</a:t>
+              <a:t>De la donnée brute à l'analyse, en trois étapes</a:t>
             </a:r>
           </a:p>
         </p:txBody>
@@ -5202,6 +5432,943 @@
                 <a:latin typeface="Calibri"/>
               </a:rPr>
               <a:t>3</a:t>
+            </a:r>
+          </a:p>
+        </p:txBody>
+      </p:sp>
+      <p:sp>
+        <p:nvSpPr>
+          <p:cNvPr id="30" name="Rounded Rectangle 29"/>
+          <p:cNvSpPr/>
+          <p:nvPr/>
+        </p:nvSpPr>
+        <p:spPr>
+          <a:xfrm>
+            <a:off x="502920" y="1691640"/>
+            <a:ext cx="3401568" cy="4297680"/>
+          </a:xfrm>
+          <a:prstGeom prst="roundRect">
+            <a:avLst>
+              <a:gd name="adj" fmla="val 4000"/>
+            </a:avLst>
+          </a:prstGeom>
+          <a:solidFill>
+            <a:srgbClr val="F4F7F8"/>
+          </a:solidFill>
+          <a:ln w="12700">
+            <a:solidFill>
+              <a:srgbClr val="DCE5E8"/>
+            </a:solidFill>
+          </a:ln>
+          <a:effectLst/>
+        </p:spPr>
+        <p:style>
+          <a:lnRef idx="1">
+            <a:schemeClr val="accent1"/>
+          </a:lnRef>
+          <a:fillRef idx="3">
+            <a:schemeClr val="accent1"/>
+          </a:fillRef>
+          <a:effectRef idx="2">
+            <a:schemeClr val="accent1"/>
+          </a:effectRef>
+          <a:fontRef idx="minor">
+            <a:schemeClr val="lt1"/>
+          </a:fontRef>
+        </p:style>
+        <p:txBody>
+          <a:bodyPr rtlCol="0" anchor="ctr"/>
+          <a:lstStyle/>
+          <a:p>
+            <a:pPr algn="ctr"/>
+          </a:p>
+        </p:txBody>
+      </p:sp>
+      <p:sp>
+        <p:nvSpPr>
+          <p:cNvPr id="31" name="Oval 30"/>
+          <p:cNvSpPr/>
+          <p:nvPr/>
+        </p:nvSpPr>
+        <p:spPr>
+          <a:xfrm>
+            <a:off x="731520" y="1911095"/>
+            <a:ext cx="420624" cy="420624"/>
+          </a:xfrm>
+          <a:prstGeom prst="ellipse">
+            <a:avLst/>
+          </a:prstGeom>
+          <a:solidFill>
+            <a:srgbClr val="0C8792"/>
+          </a:solidFill>
+          <a:ln>
+            <a:noFill/>
+          </a:ln>
+          <a:effectLst/>
+        </p:spPr>
+        <p:style>
+          <a:lnRef idx="1">
+            <a:schemeClr val="accent1"/>
+          </a:lnRef>
+          <a:fillRef idx="3">
+            <a:schemeClr val="accent1"/>
+          </a:fillRef>
+          <a:effectRef idx="2">
+            <a:schemeClr val="accent1"/>
+          </a:effectRef>
+          <a:fontRef idx="minor">
+            <a:schemeClr val="lt1"/>
+          </a:fontRef>
+        </p:style>
+        <p:txBody>
+          <a:bodyPr rtlCol="0" anchor="ctr"/>
+          <a:lstStyle/>
+          <a:p>
+            <a:pPr algn="ctr"/>
+            <a:r>
+              <a:rPr sz="1700" b="1">
+                <a:solidFill>
+                  <a:srgbClr val="FFFFFF"/>
+                </a:solidFill>
+                <a:latin typeface="Calibri"/>
+              </a:rPr>
+              <a:t>1</a:t>
+            </a:r>
+          </a:p>
+        </p:txBody>
+      </p:sp>
+      <p:sp>
+        <p:nvSpPr>
+          <p:cNvPr id="32" name="TextBox 31"/>
+          <p:cNvSpPr txBox="1"/>
+          <p:nvPr/>
+        </p:nvSpPr>
+        <p:spPr>
+          <a:xfrm>
+            <a:off x="1252728" y="1965960"/>
+            <a:ext cx="2487168" cy="384048"/>
+          </a:xfrm>
+          <a:prstGeom prst="rect">
+            <a:avLst/>
+          </a:prstGeom>
+          <a:noFill/>
+        </p:spPr>
+        <p:txBody>
+          <a:bodyPr wrap="square">
+            <a:spAutoFit/>
+          </a:bodyPr>
+          <a:lstStyle/>
+          <a:p>
+            <a:pPr>
+              <a:lnSpc>
+                <a:spcPct val="112000"/>
+              </a:lnSpc>
+              <a:spcAft>
+                <a:spcPts val="700"/>
+              </a:spcAft>
+            </a:pPr>
+            <a:r>
+              <a:rPr sz="1600" b="1">
+                <a:solidFill>
+                  <a:srgbClr val="075D66"/>
+                </a:solidFill>
+                <a:latin typeface="Calibri"/>
+              </a:rPr>
+              <a:t>NETTOYER</a:t>
+            </a:r>
+          </a:p>
+        </p:txBody>
+      </p:sp>
+      <p:sp>
+        <p:nvSpPr>
+          <p:cNvPr id="33" name="TextBox 32"/>
+          <p:cNvSpPr txBox="1"/>
+          <p:nvPr/>
+        </p:nvSpPr>
+        <p:spPr>
+          <a:xfrm>
+            <a:off x="731520" y="2560320"/>
+            <a:ext cx="2944368" cy="3291840"/>
+          </a:xfrm>
+          <a:prstGeom prst="rect">
+            <a:avLst/>
+          </a:prstGeom>
+          <a:noFill/>
+        </p:spPr>
+        <p:txBody>
+          <a:bodyPr wrap="square">
+            <a:spAutoFit/>
+          </a:bodyPr>
+          <a:lstStyle/>
+          <a:p>
+            <a:pPr>
+              <a:lnSpc>
+                <a:spcPct val="112000"/>
+              </a:lnSpc>
+              <a:spcAft>
+                <a:spcPts val="800"/>
+              </a:spcAft>
+            </a:pPr>
+            <a:r>
+              <a:rPr sz="1250" b="1">
+                <a:solidFill>
+                  <a:srgbClr val="0C8792"/>
+                </a:solidFill>
+                <a:latin typeface="Calibri"/>
+              </a:rPr>
+              <a:t>• </a:t>
+            </a:r>
+            <a:r>
+              <a:rPr sz="1250" b="0">
+                <a:solidFill>
+                  <a:srgbClr val="142128"/>
+                </a:solidFill>
+                <a:latin typeface="Calibri"/>
+              </a:rPr>
+              <a:t>105 071 retards manquants identifiés : ce sont les vols annulés ou déroutés → exclus du calcul des retards</a:t>
+            </a:r>
+          </a:p>
+          <a:p>
+            <a:pPr>
+              <a:lnSpc>
+                <a:spcPct val="112000"/>
+              </a:lnSpc>
+              <a:spcAft>
+                <a:spcPts val="800"/>
+              </a:spcAft>
+            </a:pPr>
+            <a:r>
+              <a:rPr sz="1250" b="1">
+                <a:solidFill>
+                  <a:srgbClr val="0C8792"/>
+                </a:solidFill>
+                <a:latin typeface="Calibri"/>
+              </a:rPr>
+              <a:t>• </a:t>
+            </a:r>
+            <a:r>
+              <a:rPr sz="1250" b="0">
+                <a:solidFill>
+                  <a:srgbClr val="142128"/>
+                </a:solidFill>
+                <a:latin typeface="Calibri"/>
+              </a:rPr>
+              <a:t>Codes aéroports incohérents en octobre → mois écarté de la seule analyse des routes (2,7 % des annulations)</a:t>
+            </a:r>
+          </a:p>
+        </p:txBody>
+      </p:sp>
+      <p:sp>
+        <p:nvSpPr>
+          <p:cNvPr id="34" name="Chevron 33"/>
+          <p:cNvSpPr/>
+          <p:nvPr/>
+        </p:nvSpPr>
+        <p:spPr>
+          <a:xfrm>
+            <a:off x="3950208" y="3694176"/>
+            <a:ext cx="292607" cy="292608"/>
+          </a:xfrm>
+          <a:prstGeom prst="chevron">
+            <a:avLst/>
+          </a:prstGeom>
+          <a:solidFill>
+            <a:srgbClr val="0C8792"/>
+          </a:solidFill>
+          <a:ln>
+            <a:noFill/>
+          </a:ln>
+          <a:effectLst/>
+        </p:spPr>
+        <p:style>
+          <a:lnRef idx="1">
+            <a:schemeClr val="accent1"/>
+          </a:lnRef>
+          <a:fillRef idx="3">
+            <a:schemeClr val="accent1"/>
+          </a:fillRef>
+          <a:effectRef idx="2">
+            <a:schemeClr val="accent1"/>
+          </a:effectRef>
+          <a:fontRef idx="minor">
+            <a:schemeClr val="lt1"/>
+          </a:fontRef>
+        </p:style>
+        <p:txBody>
+          <a:bodyPr rtlCol="0" anchor="ctr"/>
+          <a:lstStyle/>
+          <a:p>
+            <a:pPr algn="ctr"/>
+          </a:p>
+        </p:txBody>
+      </p:sp>
+      <p:sp>
+        <p:nvSpPr>
+          <p:cNvPr id="35" name="Rounded Rectangle 34"/>
+          <p:cNvSpPr/>
+          <p:nvPr/>
+        </p:nvSpPr>
+        <p:spPr>
+          <a:xfrm>
+            <a:off x="4288536" y="1691640"/>
+            <a:ext cx="3401568" cy="4297680"/>
+          </a:xfrm>
+          <a:prstGeom prst="roundRect">
+            <a:avLst>
+              <a:gd name="adj" fmla="val 4000"/>
+            </a:avLst>
+          </a:prstGeom>
+          <a:solidFill>
+            <a:srgbClr val="F4F7F8"/>
+          </a:solidFill>
+          <a:ln w="12700">
+            <a:solidFill>
+              <a:srgbClr val="DCE5E8"/>
+            </a:solidFill>
+          </a:ln>
+          <a:effectLst/>
+        </p:spPr>
+        <p:style>
+          <a:lnRef idx="1">
+            <a:schemeClr val="accent1"/>
+          </a:lnRef>
+          <a:fillRef idx="3">
+            <a:schemeClr val="accent1"/>
+          </a:fillRef>
+          <a:effectRef idx="2">
+            <a:schemeClr val="accent1"/>
+          </a:effectRef>
+          <a:fontRef idx="minor">
+            <a:schemeClr val="lt1"/>
+          </a:fontRef>
+        </p:style>
+        <p:txBody>
+          <a:bodyPr rtlCol="0" anchor="ctr"/>
+          <a:lstStyle/>
+          <a:p>
+            <a:pPr algn="ctr"/>
+          </a:p>
+        </p:txBody>
+      </p:sp>
+      <p:sp>
+        <p:nvSpPr>
+          <p:cNvPr id="36" name="Oval 35"/>
+          <p:cNvSpPr/>
+          <p:nvPr/>
+        </p:nvSpPr>
+        <p:spPr>
+          <a:xfrm>
+            <a:off x="4517136" y="1911095"/>
+            <a:ext cx="420624" cy="420624"/>
+          </a:xfrm>
+          <a:prstGeom prst="ellipse">
+            <a:avLst/>
+          </a:prstGeom>
+          <a:solidFill>
+            <a:srgbClr val="0C8792"/>
+          </a:solidFill>
+          <a:ln>
+            <a:noFill/>
+          </a:ln>
+          <a:effectLst/>
+        </p:spPr>
+        <p:style>
+          <a:lnRef idx="1">
+            <a:schemeClr val="accent1"/>
+          </a:lnRef>
+          <a:fillRef idx="3">
+            <a:schemeClr val="accent1"/>
+          </a:fillRef>
+          <a:effectRef idx="2">
+            <a:schemeClr val="accent1"/>
+          </a:effectRef>
+          <a:fontRef idx="minor">
+            <a:schemeClr val="lt1"/>
+          </a:fontRef>
+        </p:style>
+        <p:txBody>
+          <a:bodyPr rtlCol="0" anchor="ctr"/>
+          <a:lstStyle/>
+          <a:p>
+            <a:pPr algn="ctr"/>
+            <a:r>
+              <a:rPr sz="1700" b="1">
+                <a:solidFill>
+                  <a:srgbClr val="FFFFFF"/>
+                </a:solidFill>
+                <a:latin typeface="Calibri"/>
+              </a:rPr>
+              <a:t>2</a:t>
+            </a:r>
+          </a:p>
+        </p:txBody>
+      </p:sp>
+      <p:sp>
+        <p:nvSpPr>
+          <p:cNvPr id="37" name="TextBox 36"/>
+          <p:cNvSpPr txBox="1"/>
+          <p:nvPr/>
+        </p:nvSpPr>
+        <p:spPr>
+          <a:xfrm>
+            <a:off x="5038344" y="1965960"/>
+            <a:ext cx="2487168" cy="384048"/>
+          </a:xfrm>
+          <a:prstGeom prst="rect">
+            <a:avLst/>
+          </a:prstGeom>
+          <a:noFill/>
+        </p:spPr>
+        <p:txBody>
+          <a:bodyPr wrap="square">
+            <a:spAutoFit/>
+          </a:bodyPr>
+          <a:lstStyle/>
+          <a:p>
+            <a:pPr>
+              <a:lnSpc>
+                <a:spcPct val="112000"/>
+              </a:lnSpc>
+              <a:spcAft>
+                <a:spcPts val="700"/>
+              </a:spcAft>
+            </a:pPr>
+            <a:r>
+              <a:rPr sz="1600" b="1">
+                <a:solidFill>
+                  <a:srgbClr val="075D66"/>
+                </a:solidFill>
+                <a:latin typeface="Calibri"/>
+              </a:rPr>
+              <a:t>CONSTRUIRE</a:t>
+            </a:r>
+          </a:p>
+        </p:txBody>
+      </p:sp>
+      <p:sp>
+        <p:nvSpPr>
+          <p:cNvPr id="38" name="TextBox 37"/>
+          <p:cNvSpPr txBox="1"/>
+          <p:nvPr/>
+        </p:nvSpPr>
+        <p:spPr>
+          <a:xfrm>
+            <a:off x="4517136" y="2560320"/>
+            <a:ext cx="2944368" cy="3291840"/>
+          </a:xfrm>
+          <a:prstGeom prst="rect">
+            <a:avLst/>
+          </a:prstGeom>
+          <a:noFill/>
+        </p:spPr>
+        <p:txBody>
+          <a:bodyPr wrap="square">
+            <a:spAutoFit/>
+          </a:bodyPr>
+          <a:lstStyle/>
+          <a:p>
+            <a:pPr>
+              <a:lnSpc>
+                <a:spcPct val="112000"/>
+              </a:lnSpc>
+              <a:spcAft>
+                <a:spcPts val="800"/>
+              </a:spcAft>
+            </a:pPr>
+            <a:r>
+              <a:rPr sz="1250" b="1">
+                <a:solidFill>
+                  <a:srgbClr val="0C8792"/>
+                </a:solidFill>
+                <a:latin typeface="Calibri"/>
+              </a:rPr>
+              <a:t>• </a:t>
+            </a:r>
+            <a:r>
+              <a:rPr sz="1250" b="0">
+                <a:solidFill>
+                  <a:srgbClr val="142128"/>
+                </a:solidFill>
+                <a:latin typeface="Calibri"/>
+              </a:rPr>
+              <a:t>Retard officiel : arrivée à 15 min ou plus (norme US DOT)</a:t>
+            </a:r>
+          </a:p>
+          <a:p>
+            <a:pPr>
+              <a:lnSpc>
+                <a:spcPct val="112000"/>
+              </a:lnSpc>
+              <a:spcAft>
+                <a:spcPts val="800"/>
+              </a:spcAft>
+            </a:pPr>
+            <a:r>
+              <a:rPr sz="1250" b="1">
+                <a:solidFill>
+                  <a:srgbClr val="0C8792"/>
+                </a:solidFill>
+                <a:latin typeface="Calibri"/>
+              </a:rPr>
+              <a:t>• </a:t>
+            </a:r>
+            <a:r>
+              <a:rPr sz="1250" b="0">
+                <a:solidFill>
+                  <a:srgbClr val="142128"/>
+                </a:solidFill>
+                <a:latin typeface="Calibri"/>
+              </a:rPr>
+              <a:t>Vol long : 1500 miles ou plus</a:t>
+            </a:r>
+          </a:p>
+          <a:p>
+            <a:pPr>
+              <a:lnSpc>
+                <a:spcPct val="112000"/>
+              </a:lnSpc>
+              <a:spcAft>
+                <a:spcPts val="800"/>
+              </a:spcAft>
+            </a:pPr>
+            <a:r>
+              <a:rPr sz="1250" b="1">
+                <a:solidFill>
+                  <a:srgbClr val="0C8792"/>
+                </a:solidFill>
+                <a:latin typeface="Calibri"/>
+              </a:rPr>
+              <a:t>• </a:t>
+            </a:r>
+            <a:r>
+              <a:rPr sz="1250" b="0">
+                <a:solidFill>
+                  <a:srgbClr val="142128"/>
+                </a:solidFill>
+                <a:latin typeface="Calibri"/>
+              </a:rPr>
+              <a:t>Fenêtres de vacances 2015 bornées explicitement</a:t>
+            </a:r>
+          </a:p>
+          <a:p>
+            <a:pPr>
+              <a:lnSpc>
+                <a:spcPct val="112000"/>
+              </a:lnSpc>
+              <a:spcAft>
+                <a:spcPts val="800"/>
+              </a:spcAft>
+            </a:pPr>
+            <a:r>
+              <a:rPr sz="1250" b="1">
+                <a:solidFill>
+                  <a:srgbClr val="0C8792"/>
+                </a:solidFill>
+                <a:latin typeface="Calibri"/>
+              </a:rPr>
+              <a:t>• </a:t>
+            </a:r>
+            <a:r>
+              <a:rPr sz="1250" b="0">
+                <a:solidFill>
+                  <a:srgbClr val="142128"/>
+                </a:solidFill>
+                <a:latin typeface="Calibri"/>
+              </a:rPr>
+              <a:t>Routes origine → destination</a:t>
+            </a:r>
+          </a:p>
+        </p:txBody>
+      </p:sp>
+      <p:sp>
+        <p:nvSpPr>
+          <p:cNvPr id="39" name="Chevron 38"/>
+          <p:cNvSpPr/>
+          <p:nvPr/>
+        </p:nvSpPr>
+        <p:spPr>
+          <a:xfrm>
+            <a:off x="7735824" y="3694176"/>
+            <a:ext cx="292607" cy="292608"/>
+          </a:xfrm>
+          <a:prstGeom prst="chevron">
+            <a:avLst/>
+          </a:prstGeom>
+          <a:solidFill>
+            <a:srgbClr val="0C8792"/>
+          </a:solidFill>
+          <a:ln>
+            <a:noFill/>
+          </a:ln>
+          <a:effectLst/>
+        </p:spPr>
+        <p:style>
+          <a:lnRef idx="1">
+            <a:schemeClr val="accent1"/>
+          </a:lnRef>
+          <a:fillRef idx="3">
+            <a:schemeClr val="accent1"/>
+          </a:fillRef>
+          <a:effectRef idx="2">
+            <a:schemeClr val="accent1"/>
+          </a:effectRef>
+          <a:fontRef idx="minor">
+            <a:schemeClr val="lt1"/>
+          </a:fontRef>
+        </p:style>
+        <p:txBody>
+          <a:bodyPr rtlCol="0" anchor="ctr"/>
+          <a:lstStyle/>
+          <a:p>
+            <a:pPr algn="ctr"/>
+          </a:p>
+        </p:txBody>
+      </p:sp>
+      <p:sp>
+        <p:nvSpPr>
+          <p:cNvPr id="40" name="Rounded Rectangle 39"/>
+          <p:cNvSpPr/>
+          <p:nvPr/>
+        </p:nvSpPr>
+        <p:spPr>
+          <a:xfrm>
+            <a:off x="8074152" y="1691640"/>
+            <a:ext cx="3401568" cy="4297680"/>
+          </a:xfrm>
+          <a:prstGeom prst="roundRect">
+            <a:avLst>
+              <a:gd name="adj" fmla="val 4000"/>
+            </a:avLst>
+          </a:prstGeom>
+          <a:solidFill>
+            <a:srgbClr val="F4F7F8"/>
+          </a:solidFill>
+          <a:ln w="12700">
+            <a:solidFill>
+              <a:srgbClr val="DCE5E8"/>
+            </a:solidFill>
+          </a:ln>
+          <a:effectLst/>
+        </p:spPr>
+        <p:style>
+          <a:lnRef idx="1">
+            <a:schemeClr val="accent1"/>
+          </a:lnRef>
+          <a:fillRef idx="3">
+            <a:schemeClr val="accent1"/>
+          </a:fillRef>
+          <a:effectRef idx="2">
+            <a:schemeClr val="accent1"/>
+          </a:effectRef>
+          <a:fontRef idx="minor">
+            <a:schemeClr val="lt1"/>
+          </a:fontRef>
+        </p:style>
+        <p:txBody>
+          <a:bodyPr rtlCol="0" anchor="ctr"/>
+          <a:lstStyle/>
+          <a:p>
+            <a:pPr algn="ctr"/>
+          </a:p>
+        </p:txBody>
+      </p:sp>
+      <p:sp>
+        <p:nvSpPr>
+          <p:cNvPr id="41" name="Oval 40"/>
+          <p:cNvSpPr/>
+          <p:nvPr/>
+        </p:nvSpPr>
+        <p:spPr>
+          <a:xfrm>
+            <a:off x="8302752" y="1911095"/>
+            <a:ext cx="420624" cy="420624"/>
+          </a:xfrm>
+          <a:prstGeom prst="ellipse">
+            <a:avLst/>
+          </a:prstGeom>
+          <a:solidFill>
+            <a:srgbClr val="0C8792"/>
+          </a:solidFill>
+          <a:ln>
+            <a:noFill/>
+          </a:ln>
+          <a:effectLst/>
+        </p:spPr>
+        <p:style>
+          <a:lnRef idx="1">
+            <a:schemeClr val="accent1"/>
+          </a:lnRef>
+          <a:fillRef idx="3">
+            <a:schemeClr val="accent1"/>
+          </a:fillRef>
+          <a:effectRef idx="2">
+            <a:schemeClr val="accent1"/>
+          </a:effectRef>
+          <a:fontRef idx="minor">
+            <a:schemeClr val="lt1"/>
+          </a:fontRef>
+        </p:style>
+        <p:txBody>
+          <a:bodyPr rtlCol="0" anchor="ctr"/>
+          <a:lstStyle/>
+          <a:p>
+            <a:pPr algn="ctr"/>
+            <a:r>
+              <a:rPr sz="1700" b="1">
+                <a:solidFill>
+                  <a:srgbClr val="FFFFFF"/>
+                </a:solidFill>
+                <a:latin typeface="Calibri"/>
+              </a:rPr>
+              <a:t>3</a:t>
+            </a:r>
+          </a:p>
+        </p:txBody>
+      </p:sp>
+      <p:sp>
+        <p:nvSpPr>
+          <p:cNvPr id="42" name="TextBox 41"/>
+          <p:cNvSpPr txBox="1"/>
+          <p:nvPr/>
+        </p:nvSpPr>
+        <p:spPr>
+          <a:xfrm>
+            <a:off x="8823960" y="1965960"/>
+            <a:ext cx="2487168" cy="384048"/>
+          </a:xfrm>
+          <a:prstGeom prst="rect">
+            <a:avLst/>
+          </a:prstGeom>
+          <a:noFill/>
+        </p:spPr>
+        <p:txBody>
+          <a:bodyPr wrap="square">
+            <a:spAutoFit/>
+          </a:bodyPr>
+          <a:lstStyle/>
+          <a:p>
+            <a:pPr>
+              <a:lnSpc>
+                <a:spcPct val="112000"/>
+              </a:lnSpc>
+              <a:spcAft>
+                <a:spcPts val="700"/>
+              </a:spcAft>
+            </a:pPr>
+            <a:r>
+              <a:rPr sz="1600" b="1">
+                <a:solidFill>
+                  <a:srgbClr val="075D66"/>
+                </a:solidFill>
+                <a:latin typeface="Calibri"/>
+              </a:rPr>
+              <a:t>ANALYSER</a:t>
+            </a:r>
+          </a:p>
+        </p:txBody>
+      </p:sp>
+      <p:sp>
+        <p:nvSpPr>
+          <p:cNvPr id="43" name="TextBox 42"/>
+          <p:cNvSpPr txBox="1"/>
+          <p:nvPr/>
+        </p:nvSpPr>
+        <p:spPr>
+          <a:xfrm>
+            <a:off x="8302752" y="2560320"/>
+            <a:ext cx="2944368" cy="3291840"/>
+          </a:xfrm>
+          <a:prstGeom prst="rect">
+            <a:avLst/>
+          </a:prstGeom>
+          <a:noFill/>
+        </p:spPr>
+        <p:txBody>
+          <a:bodyPr wrap="square">
+            <a:spAutoFit/>
+          </a:bodyPr>
+          <a:lstStyle/>
+          <a:p>
+            <a:pPr>
+              <a:lnSpc>
+                <a:spcPct val="110000"/>
+              </a:lnSpc>
+              <a:spcAft>
+                <a:spcPts val="700"/>
+              </a:spcAft>
+            </a:pPr>
+            <a:r>
+              <a:rPr sz="1250" b="1">
+                <a:solidFill>
+                  <a:srgbClr val="0C8792"/>
+                </a:solidFill>
+                <a:latin typeface="Calibri"/>
+              </a:rPr>
+              <a:t>• </a:t>
+            </a:r>
+            <a:r>
+              <a:rPr sz="1250">
+                <a:solidFill>
+                  <a:srgbClr val="142128"/>
+                </a:solidFill>
+                <a:latin typeface="Calibri"/>
+              </a:rPr>
+              <a:t>Agrégations par jour, compagnie et route</a:t>
+            </a:r>
+          </a:p>
+          <a:p>
+            <a:pPr>
+              <a:lnSpc>
+                <a:spcPct val="110000"/>
+              </a:lnSpc>
+              <a:spcAft>
+                <a:spcPts val="700"/>
+              </a:spcAft>
+            </a:pPr>
+            <a:r>
+              <a:rPr sz="1250" b="1">
+                <a:solidFill>
+                  <a:srgbClr val="0C8792"/>
+                </a:solidFill>
+                <a:latin typeface="Calibri"/>
+              </a:rPr>
+              <a:t>• </a:t>
+            </a:r>
+            <a:r>
+              <a:rPr sz="1250">
+                <a:solidFill>
+                  <a:srgbClr val="142128"/>
+                </a:solidFill>
+                <a:latin typeface="Calibri"/>
+              </a:rPr>
+              <a:t>Chaque période de vacances comparée à une référence comparable</a:t>
+            </a:r>
+          </a:p>
+          <a:p>
+            <a:pPr>
+              <a:lnSpc>
+                <a:spcPct val="110000"/>
+              </a:lnSpc>
+              <a:spcAft>
+                <a:spcPts val="700"/>
+              </a:spcAft>
+            </a:pPr>
+            <a:r>
+              <a:rPr sz="1250" b="1">
+                <a:solidFill>
+                  <a:srgbClr val="0C8792"/>
+                </a:solidFill>
+                <a:latin typeface="Calibri"/>
+              </a:rPr>
+              <a:t>• </a:t>
+            </a:r>
+            <a:r>
+              <a:rPr sz="1250">
+                <a:solidFill>
+                  <a:srgbClr val="142128"/>
+                </a:solidFill>
+                <a:latin typeface="Calibri"/>
+              </a:rPr>
+              <a:t>Part des retards portée par les vols longs</a:t>
+            </a:r>
+          </a:p>
+          <a:p>
+            <a:pPr>
+              <a:lnSpc>
+                <a:spcPct val="110000"/>
+              </a:lnSpc>
+              <a:spcAft>
+                <a:spcPts val="700"/>
+              </a:spcAft>
+            </a:pPr>
+            <a:r>
+              <a:rPr sz="1250" b="1">
+                <a:solidFill>
+                  <a:srgbClr val="0C8792"/>
+                </a:solidFill>
+                <a:latin typeface="Calibri"/>
+              </a:rPr>
+              <a:t>• </a:t>
+            </a:r>
+            <a:r>
+              <a:rPr sz="1250">
+                <a:solidFill>
+                  <a:srgbClr val="142128"/>
+                </a:solidFill>
+                <a:latin typeface="Calibri"/>
+              </a:rPr>
+              <a:t>Concentration des annulations rapportée à celle du trafic</a:t>
+            </a:r>
+          </a:p>
+          <a:p>
+            <a:pPr>
+              <a:lnSpc>
+                <a:spcPct val="110000"/>
+              </a:lnSpc>
+              <a:spcAft>
+                <a:spcPts val="700"/>
+              </a:spcAft>
+            </a:pPr>
+            <a:r>
+              <a:rPr sz="1250" b="1">
+                <a:solidFill>
+                  <a:srgbClr val="0C8792"/>
+                </a:solidFill>
+                <a:latin typeface="Calibri"/>
+              </a:rPr>
+              <a:t>• </a:t>
+            </a:r>
+            <a:r>
+              <a:rPr sz="1250">
+                <a:solidFill>
+                  <a:srgbClr val="142128"/>
+                </a:solidFill>
+                <a:latin typeface="Calibri"/>
+              </a:rPr>
+              <a:t>Robustesse : résultats vérifiés sur d'autres seuils et périmètres</a:t>
+            </a:r>
+          </a:p>
+        </p:txBody>
+      </p:sp>
+      <p:sp>
+        <p:nvSpPr>
+          <p:cNvPr id="44" name="TextBox 43"/>
+          <p:cNvSpPr txBox="1"/>
+          <p:nvPr/>
+        </p:nvSpPr>
+        <p:spPr>
+          <a:xfrm>
+            <a:off x="502920" y="6089904"/>
+            <a:ext cx="11155680" cy="320040"/>
+          </a:xfrm>
+          <a:prstGeom prst="rect">
+            <a:avLst/>
+          </a:prstGeom>
+          <a:noFill/>
+        </p:spPr>
+        <p:txBody>
+          <a:bodyPr wrap="square">
+            <a:spAutoFit/>
+          </a:bodyPr>
+          <a:lstStyle/>
+          <a:p>
+            <a:r>
+              <a:rPr sz="1150" b="1">
+                <a:solidFill>
+                  <a:srgbClr val="075D66"/>
+                </a:solidFill>
+                <a:latin typeface="Calibri"/>
+              </a:rPr>
+              <a:t>Volumétrie — </a:t>
+            </a:r>
+            <a:r>
+              <a:rPr sz="1150" b="0">
+                <a:solidFill>
+                  <a:srgbClr val="687985"/>
+                </a:solidFill>
+                <a:latin typeface="Calibri"/>
+              </a:rPr>
+              <a:t>fichier des vols de 592 Mo chargé en types compacts (~350 Mo en mémoire) ; la chaîne complète s'exécute en moins de 2 minutes</a:t>
             </a:r>
           </a:p>
         </p:txBody>
@@ -6062,14 +7229,14 @@
       </p:sp>
       <p:pic>
         <p:nvPicPr>
-          <p:cNvPr id="8" name="Picture 7" descr="capture_finale_accents.png"/>
+          <p:cNvPr id="8" name="Picture 7" descr="capture_slide5_commit2.png"/>
           <p:cNvPicPr>
             <a:picLocks noChangeAspect="1"/>
           </p:cNvPicPr>
           <p:nvPr/>
         </p:nvPicPr>
         <p:blipFill>
-          <a:blip r:embed="rId3"/>
+          <a:blip r:embed="rId2"/>
           <a:stretch>
             <a:fillRect/>
           </a:stretch>

</xml_diff>